<commit_message>
Bring presentations up to date
</commit_message>
<xml_diff>
--- a/instructors/L1-Introduction.pptx
+++ b/instructors/L1-Introduction.pptx
@@ -4,18 +4,23 @@
   <p:sldMasterIdLst>
     <p:sldMasterId id="2147483648" r:id="rId1"/>
   </p:sldMasterIdLst>
+  <p:notesMasterIdLst>
+    <p:notesMasterId r:id="rId15"/>
+  </p:notesMasterIdLst>
   <p:sldIdLst>
     <p:sldId id="256" r:id="rId2"/>
     <p:sldId id="1685" r:id="rId3"/>
     <p:sldId id="1684" r:id="rId4"/>
-    <p:sldId id="1662" r:id="rId5"/>
-    <p:sldId id="1664" r:id="rId6"/>
-    <p:sldId id="257" r:id="rId7"/>
-    <p:sldId id="258" r:id="rId8"/>
-    <p:sldId id="259" r:id="rId9"/>
-    <p:sldId id="261" r:id="rId10"/>
-    <p:sldId id="262" r:id="rId11"/>
-    <p:sldId id="263" r:id="rId12"/>
+    <p:sldId id="1716" r:id="rId5"/>
+    <p:sldId id="1740" r:id="rId6"/>
+    <p:sldId id="1662" r:id="rId7"/>
+    <p:sldId id="1664" r:id="rId8"/>
+    <p:sldId id="257" r:id="rId9"/>
+    <p:sldId id="258" r:id="rId10"/>
+    <p:sldId id="259" r:id="rId11"/>
+    <p:sldId id="261" r:id="rId12"/>
+    <p:sldId id="262" r:id="rId13"/>
+    <p:sldId id="263" r:id="rId14"/>
   </p:sldIdLst>
   <p:sldSz cx="12192000" cy="6858000"/>
   <p:notesSz cx="6858000" cy="9144000"/>
@@ -122,476 +127,491 @@
 </p:presentation>
 </file>
 
-<file path=ppt/revisionInfo.xml><?xml version="1.0" encoding="utf-8"?>
-<p1510:revInfo xmlns:a="http://schemas.openxmlformats.org/drawingml/2006/main" xmlns:r="http://schemas.openxmlformats.org/officeDocument/2006/relationships" xmlns:p1510="http://schemas.microsoft.com/office/powerpoint/2015/10/main">
-  <p1510:revLst>
-    <p1510:client id="{3F16AB9C-AEAB-FF4F-A4CC-8A61C9912EB8}" v="16" dt="2025-10-07T13:23:59.269"/>
-  </p1510:revLst>
-</p1510:revInfo>
-</file>
-
 <file path=ppt/changesInfos/changesInfo1.xml><?xml version="1.0" encoding="utf-8"?>
 <pc:chgInfo xmlns:a="http://schemas.openxmlformats.org/drawingml/2006/main" xmlns:r="http://schemas.openxmlformats.org/officeDocument/2006/relationships" xmlns:ac="http://schemas.microsoft.com/office/drawing/2013/main/command" xmlns:pc="http://schemas.microsoft.com/office/powerpoint/2013/main/command">
   <pc:docChgLst>
     <pc:chgData name="Andrew Turner" userId="9b60647a-c825-4266-aafa-670849c64782" providerId="ADAL" clId="{292526B5-234E-5EAA-AFB8-0412B8CA4453}"/>
     <pc:docChg chg="undo custSel addSld delSld modSld modMainMaster">
-      <pc:chgData name="Andrew Turner" userId="9b60647a-c825-4266-aafa-670849c64782" providerId="ADAL" clId="{292526B5-234E-5EAA-AFB8-0412B8CA4453}" dt="2025-10-07T13:24:07.662" v="106" actId="14100"/>
+      <pc:chgData name="Andrew Turner" userId="9b60647a-c825-4266-aafa-670849c64782" providerId="ADAL" clId="{292526B5-234E-5EAA-AFB8-0412B8CA4453}" dt="2026-10-01T19:08:23.065" v="109" actId="207"/>
       <pc:docMkLst>
         <pc:docMk/>
       </pc:docMkLst>
-      <pc:sldChg chg="modSp setBg">
-        <pc:chgData name="Andrew Turner" userId="9b60647a-c825-4266-aafa-670849c64782" providerId="ADAL" clId="{292526B5-234E-5EAA-AFB8-0412B8CA4453}" dt="2025-10-07T13:19:01.146" v="15"/>
-        <pc:sldMkLst>
-          <pc:docMk/>
-          <pc:sldMk cId="3551035755" sldId="256"/>
-        </pc:sldMkLst>
-        <pc:spChg chg="mod">
-          <ac:chgData name="Andrew Turner" userId="9b60647a-c825-4266-aafa-670849c64782" providerId="ADAL" clId="{292526B5-234E-5EAA-AFB8-0412B8CA4453}" dt="2025-10-07T13:18:08.254" v="12"/>
-          <ac:spMkLst>
-            <pc:docMk/>
-            <pc:sldMk cId="3551035755" sldId="256"/>
-            <ac:spMk id="2" creationId="{662C71DA-7F2A-A8EC-3829-5ECA4E32E910}"/>
-          </ac:spMkLst>
-        </pc:spChg>
-        <pc:spChg chg="mod">
-          <ac:chgData name="Andrew Turner" userId="9b60647a-c825-4266-aafa-670849c64782" providerId="ADAL" clId="{292526B5-234E-5EAA-AFB8-0412B8CA4453}" dt="2025-10-07T13:18:08.254" v="12"/>
-          <ac:spMkLst>
-            <pc:docMk/>
-            <pc:sldMk cId="3551035755" sldId="256"/>
-            <ac:spMk id="3" creationId="{D954F7DC-26EE-43DF-D4E0-28174E9A1FFF}"/>
-          </ac:spMkLst>
-        </pc:spChg>
-      </pc:sldChg>
       <pc:sldChg chg="modSp mod">
-        <pc:chgData name="Andrew Turner" userId="9b60647a-c825-4266-aafa-670849c64782" providerId="ADAL" clId="{292526B5-234E-5EAA-AFB8-0412B8CA4453}" dt="2025-10-07T13:18:08.254" v="12"/>
-        <pc:sldMkLst>
-          <pc:docMk/>
-          <pc:sldMk cId="3369251669" sldId="257"/>
-        </pc:sldMkLst>
-        <pc:spChg chg="mod">
-          <ac:chgData name="Andrew Turner" userId="9b60647a-c825-4266-aafa-670849c64782" providerId="ADAL" clId="{292526B5-234E-5EAA-AFB8-0412B8CA4453}" dt="2025-10-07T13:18:08.254" v="12"/>
-          <ac:spMkLst>
-            <pc:docMk/>
-            <pc:sldMk cId="3369251669" sldId="257"/>
-            <ac:spMk id="2" creationId="{8A906867-1D2C-FE55-5DD4-17E2FD176122}"/>
-          </ac:spMkLst>
-        </pc:spChg>
-        <pc:spChg chg="mod">
-          <ac:chgData name="Andrew Turner" userId="9b60647a-c825-4266-aafa-670849c64782" providerId="ADAL" clId="{292526B5-234E-5EAA-AFB8-0412B8CA4453}" dt="2025-10-07T13:18:08.254" v="12"/>
-          <ac:spMkLst>
-            <pc:docMk/>
-            <pc:sldMk cId="3369251669" sldId="257"/>
-            <ac:spMk id="3" creationId="{BEB72345-A1CA-0D4A-BC3A-3D4145B2D051}"/>
-          </ac:spMkLst>
-        </pc:spChg>
-      </pc:sldChg>
-      <pc:sldChg chg="modSp mod">
-        <pc:chgData name="Andrew Turner" userId="9b60647a-c825-4266-aafa-670849c64782" providerId="ADAL" clId="{292526B5-234E-5EAA-AFB8-0412B8CA4453}" dt="2025-10-07T13:18:08.254" v="12"/>
-        <pc:sldMkLst>
-          <pc:docMk/>
-          <pc:sldMk cId="2548529128" sldId="258"/>
-        </pc:sldMkLst>
-        <pc:spChg chg="mod">
-          <ac:chgData name="Andrew Turner" userId="9b60647a-c825-4266-aafa-670849c64782" providerId="ADAL" clId="{292526B5-234E-5EAA-AFB8-0412B8CA4453}" dt="2025-10-07T13:18:08.254" v="12"/>
-          <ac:spMkLst>
-            <pc:docMk/>
-            <pc:sldMk cId="2548529128" sldId="258"/>
-            <ac:spMk id="2" creationId="{BC120409-6EB5-E11A-0230-8D3F0B1134E9}"/>
-          </ac:spMkLst>
-        </pc:spChg>
-        <pc:spChg chg="mod">
-          <ac:chgData name="Andrew Turner" userId="9b60647a-c825-4266-aafa-670849c64782" providerId="ADAL" clId="{292526B5-234E-5EAA-AFB8-0412B8CA4453}" dt="2025-10-07T13:18:08.254" v="12"/>
-          <ac:spMkLst>
-            <pc:docMk/>
-            <pc:sldMk cId="2548529128" sldId="258"/>
-            <ac:spMk id="3" creationId="{FE3C14D3-ECF9-CFCD-8788-F6332655D99D}"/>
-          </ac:spMkLst>
-        </pc:spChg>
-      </pc:sldChg>
-      <pc:sldChg chg="modSp">
-        <pc:chgData name="Andrew Turner" userId="9b60647a-c825-4266-aafa-670849c64782" providerId="ADAL" clId="{292526B5-234E-5EAA-AFB8-0412B8CA4453}" dt="2025-10-07T13:18:08.254" v="12"/>
-        <pc:sldMkLst>
-          <pc:docMk/>
-          <pc:sldMk cId="1336928419" sldId="259"/>
-        </pc:sldMkLst>
-        <pc:spChg chg="mod">
-          <ac:chgData name="Andrew Turner" userId="9b60647a-c825-4266-aafa-670849c64782" providerId="ADAL" clId="{292526B5-234E-5EAA-AFB8-0412B8CA4453}" dt="2025-10-07T13:18:08.254" v="12"/>
-          <ac:spMkLst>
-            <pc:docMk/>
-            <pc:sldMk cId="1336928419" sldId="259"/>
-            <ac:spMk id="2" creationId="{534421AB-2E7C-0C8C-8B80-12FBE0BFF8D1}"/>
-          </ac:spMkLst>
-        </pc:spChg>
-        <pc:spChg chg="mod">
-          <ac:chgData name="Andrew Turner" userId="9b60647a-c825-4266-aafa-670849c64782" providerId="ADAL" clId="{292526B5-234E-5EAA-AFB8-0412B8CA4453}" dt="2025-10-07T13:18:08.254" v="12"/>
-          <ac:spMkLst>
-            <pc:docMk/>
-            <pc:sldMk cId="1336928419" sldId="259"/>
-            <ac:spMk id="3" creationId="{4D3BEC50-78D0-1BFE-3014-63A622CBED21}"/>
-          </ac:spMkLst>
-        </pc:spChg>
-      </pc:sldChg>
-      <pc:sldChg chg="modSp del">
-        <pc:chgData name="Andrew Turner" userId="9b60647a-c825-4266-aafa-670849c64782" providerId="ADAL" clId="{292526B5-234E-5EAA-AFB8-0412B8CA4453}" dt="2025-10-07T13:20:23.264" v="23" actId="2696"/>
-        <pc:sldMkLst>
-          <pc:docMk/>
-          <pc:sldMk cId="2885870814" sldId="260"/>
-        </pc:sldMkLst>
-        <pc:spChg chg="mod">
-          <ac:chgData name="Andrew Turner" userId="9b60647a-c825-4266-aafa-670849c64782" providerId="ADAL" clId="{292526B5-234E-5EAA-AFB8-0412B8CA4453}" dt="2025-10-07T13:18:08.254" v="12"/>
-          <ac:spMkLst>
-            <pc:docMk/>
-            <pc:sldMk cId="2885870814" sldId="260"/>
-            <ac:spMk id="2" creationId="{6122D8C7-81EF-0C15-D1DB-3237CEF1A13A}"/>
-          </ac:spMkLst>
-        </pc:spChg>
-        <pc:spChg chg="mod">
-          <ac:chgData name="Andrew Turner" userId="9b60647a-c825-4266-aafa-670849c64782" providerId="ADAL" clId="{292526B5-234E-5EAA-AFB8-0412B8CA4453}" dt="2025-10-07T13:18:08.254" v="12"/>
-          <ac:spMkLst>
-            <pc:docMk/>
-            <pc:sldMk cId="2885870814" sldId="260"/>
-            <ac:spMk id="3" creationId="{5987DAD5-9016-F789-BBD9-ADB72C11611A}"/>
-          </ac:spMkLst>
-        </pc:spChg>
-      </pc:sldChg>
-      <pc:sldChg chg="modSp mod">
-        <pc:chgData name="Andrew Turner" userId="9b60647a-c825-4266-aafa-670849c64782" providerId="ADAL" clId="{292526B5-234E-5EAA-AFB8-0412B8CA4453}" dt="2025-10-07T13:18:08.254" v="12"/>
+        <pc:chgData name="Andrew Turner" userId="9b60647a-c825-4266-aafa-670849c64782" providerId="ADAL" clId="{292526B5-234E-5EAA-AFB8-0412B8CA4453}" dt="2026-10-01T19:08:23.065" v="109" actId="207"/>
         <pc:sldMkLst>
           <pc:docMk/>
           <pc:sldMk cId="2205958413" sldId="261"/>
         </pc:sldMkLst>
         <pc:spChg chg="mod">
-          <ac:chgData name="Andrew Turner" userId="9b60647a-c825-4266-aafa-670849c64782" providerId="ADAL" clId="{292526B5-234E-5EAA-AFB8-0412B8CA4453}" dt="2025-10-07T13:18:08.254" v="12"/>
+          <ac:chgData name="Andrew Turner" userId="9b60647a-c825-4266-aafa-670849c64782" providerId="ADAL" clId="{292526B5-234E-5EAA-AFB8-0412B8CA4453}" dt="2026-10-01T19:08:23.065" v="109" actId="207"/>
           <ac:spMkLst>
             <pc:docMk/>
             <pc:sldMk cId="2205958413" sldId="261"/>
             <ac:spMk id="2" creationId="{A14A4F2D-67FE-A40B-38A1-FE15430A041C}"/>
           </ac:spMkLst>
         </pc:spChg>
-        <pc:spChg chg="mod">
-          <ac:chgData name="Andrew Turner" userId="9b60647a-c825-4266-aafa-670849c64782" providerId="ADAL" clId="{292526B5-234E-5EAA-AFB8-0412B8CA4453}" dt="2025-10-07T13:18:08.254" v="12"/>
-          <ac:spMkLst>
-            <pc:docMk/>
-            <pc:sldMk cId="2205958413" sldId="261"/>
-            <ac:spMk id="3" creationId="{681A15F2-B311-C881-92C3-93622D9DC6C9}"/>
-          </ac:spMkLst>
-        </pc:spChg>
       </pc:sldChg>
-      <pc:sldChg chg="modSp mod">
-        <pc:chgData name="Andrew Turner" userId="9b60647a-c825-4266-aafa-670849c64782" providerId="ADAL" clId="{292526B5-234E-5EAA-AFB8-0412B8CA4453}" dt="2025-10-07T13:18:08.254" v="12"/>
-        <pc:sldMkLst>
-          <pc:docMk/>
-          <pc:sldMk cId="285989033" sldId="262"/>
-        </pc:sldMkLst>
-        <pc:spChg chg="mod">
-          <ac:chgData name="Andrew Turner" userId="9b60647a-c825-4266-aafa-670849c64782" providerId="ADAL" clId="{292526B5-234E-5EAA-AFB8-0412B8CA4453}" dt="2025-10-07T13:18:08.254" v="12"/>
-          <ac:spMkLst>
-            <pc:docMk/>
-            <pc:sldMk cId="285989033" sldId="262"/>
-            <ac:spMk id="2" creationId="{C653FCB3-0412-EB70-FD2D-95C9BA50D7F2}"/>
-          </ac:spMkLst>
-        </pc:spChg>
-        <pc:spChg chg="mod">
-          <ac:chgData name="Andrew Turner" userId="9b60647a-c825-4266-aafa-670849c64782" providerId="ADAL" clId="{292526B5-234E-5EAA-AFB8-0412B8CA4453}" dt="2025-10-07T13:18:08.254" v="12"/>
-          <ac:spMkLst>
-            <pc:docMk/>
-            <pc:sldMk cId="285989033" sldId="262"/>
-            <ac:spMk id="3" creationId="{84B4B57E-F41E-CA7F-553A-822BDE50E4E9}"/>
-          </ac:spMkLst>
-        </pc:spChg>
-      </pc:sldChg>
-      <pc:sldChg chg="modSp mod">
-        <pc:chgData name="Andrew Turner" userId="9b60647a-c825-4266-aafa-670849c64782" providerId="ADAL" clId="{292526B5-234E-5EAA-AFB8-0412B8CA4453}" dt="2025-10-07T13:23:01.494" v="74" actId="20577"/>
-        <pc:sldMkLst>
-          <pc:docMk/>
-          <pc:sldMk cId="2041110984" sldId="263"/>
-        </pc:sldMkLst>
-        <pc:spChg chg="mod">
-          <ac:chgData name="Andrew Turner" userId="9b60647a-c825-4266-aafa-670849c64782" providerId="ADAL" clId="{292526B5-234E-5EAA-AFB8-0412B8CA4453}" dt="2025-10-07T13:18:08.254" v="12"/>
-          <ac:spMkLst>
-            <pc:docMk/>
-            <pc:sldMk cId="2041110984" sldId="263"/>
-            <ac:spMk id="2" creationId="{2672F6FE-644B-1FAD-DA53-833D89175A58}"/>
-          </ac:spMkLst>
-        </pc:spChg>
-        <pc:spChg chg="mod">
-          <ac:chgData name="Andrew Turner" userId="9b60647a-c825-4266-aafa-670849c64782" providerId="ADAL" clId="{292526B5-234E-5EAA-AFB8-0412B8CA4453}" dt="2025-10-07T13:23:01.494" v="74" actId="20577"/>
-          <ac:spMkLst>
-            <pc:docMk/>
-            <pc:sldMk cId="2041110984" sldId="263"/>
-            <ac:spMk id="3" creationId="{8F6636AD-81A8-24BB-0001-488C35956831}"/>
-          </ac:spMkLst>
-        </pc:spChg>
-      </pc:sldChg>
-      <pc:sldChg chg="addSp delSp modSp new del mod">
-        <pc:chgData name="Andrew Turner" userId="9b60647a-c825-4266-aafa-670849c64782" providerId="ADAL" clId="{292526B5-234E-5EAA-AFB8-0412B8CA4453}" dt="2025-10-07T13:20:09.624" v="20" actId="2696"/>
-        <pc:sldMkLst>
-          <pc:docMk/>
-          <pc:sldMk cId="1464749923" sldId="264"/>
-        </pc:sldMkLst>
-        <pc:spChg chg="del">
-          <ac:chgData name="Andrew Turner" userId="9b60647a-c825-4266-aafa-670849c64782" providerId="ADAL" clId="{292526B5-234E-5EAA-AFB8-0412B8CA4453}" dt="2025-10-07T13:20:05.161" v="18" actId="478"/>
-          <ac:spMkLst>
-            <pc:docMk/>
-            <pc:sldMk cId="1464749923" sldId="264"/>
-            <ac:spMk id="2" creationId="{B623D26F-3499-FA5D-A72F-2094CBE0B407}"/>
-          </ac:spMkLst>
-        </pc:spChg>
-        <pc:spChg chg="del">
-          <ac:chgData name="Andrew Turner" userId="9b60647a-c825-4266-aafa-670849c64782" providerId="ADAL" clId="{292526B5-234E-5EAA-AFB8-0412B8CA4453}" dt="2025-10-07T13:20:06.472" v="19" actId="478"/>
-          <ac:spMkLst>
-            <pc:docMk/>
-            <pc:sldMk cId="1464749923" sldId="264"/>
-            <ac:spMk id="3" creationId="{365B03BE-D759-2305-FF52-326C28D8636C}"/>
-          </ac:spMkLst>
-        </pc:spChg>
-        <pc:picChg chg="add mod">
-          <ac:chgData name="Andrew Turner" userId="9b60647a-c825-4266-aafa-670849c64782" providerId="ADAL" clId="{292526B5-234E-5EAA-AFB8-0412B8CA4453}" dt="2025-10-07T13:20:01.927" v="17"/>
-          <ac:picMkLst>
-            <pc:docMk/>
-            <pc:sldMk cId="1464749923" sldId="264"/>
-            <ac:picMk id="4" creationId="{FA4D0B5E-2D7B-210E-1157-34134AEFAAA6}"/>
-          </ac:picMkLst>
-        </pc:picChg>
-      </pc:sldChg>
-      <pc:sldChg chg="modSp add mod">
-        <pc:chgData name="Andrew Turner" userId="9b60647a-c825-4266-aafa-670849c64782" providerId="ADAL" clId="{292526B5-234E-5EAA-AFB8-0412B8CA4453}" dt="2025-10-07T13:20:19.063" v="22" actId="27636"/>
-        <pc:sldMkLst>
-          <pc:docMk/>
-          <pc:sldMk cId="1332744819" sldId="1662"/>
-        </pc:sldMkLst>
-        <pc:spChg chg="mod">
-          <ac:chgData name="Andrew Turner" userId="9b60647a-c825-4266-aafa-670849c64782" providerId="ADAL" clId="{292526B5-234E-5EAA-AFB8-0412B8CA4453}" dt="2025-10-07T13:20:19.063" v="22" actId="27636"/>
-          <ac:spMkLst>
-            <pc:docMk/>
-            <pc:sldMk cId="1332744819" sldId="1662"/>
-            <ac:spMk id="3" creationId="{B28162B9-9F2A-E76E-3563-0DEAB97820C1}"/>
-          </ac:spMkLst>
-        </pc:spChg>
-      </pc:sldChg>
-      <pc:sldChg chg="addSp modSp add mod">
-        <pc:chgData name="Andrew Turner" userId="9b60647a-c825-4266-aafa-670849c64782" providerId="ADAL" clId="{292526B5-234E-5EAA-AFB8-0412B8CA4453}" dt="2025-10-07T13:22:26.576" v="71" actId="20577"/>
-        <pc:sldMkLst>
-          <pc:docMk/>
-          <pc:sldMk cId="1611218844" sldId="1664"/>
-        </pc:sldMkLst>
-        <pc:spChg chg="add mod">
-          <ac:chgData name="Andrew Turner" userId="9b60647a-c825-4266-aafa-670849c64782" providerId="ADAL" clId="{292526B5-234E-5EAA-AFB8-0412B8CA4453}" dt="2025-10-07T13:21:06.788" v="26" actId="1076"/>
-          <ac:spMkLst>
-            <pc:docMk/>
-            <pc:sldMk cId="1611218844" sldId="1664"/>
-            <ac:spMk id="2" creationId="{9A2F2E65-6E77-5CB3-8269-BF8E61E60042}"/>
-          </ac:spMkLst>
-        </pc:spChg>
-        <pc:spChg chg="add mod">
-          <ac:chgData name="Andrew Turner" userId="9b60647a-c825-4266-aafa-670849c64782" providerId="ADAL" clId="{292526B5-234E-5EAA-AFB8-0412B8CA4453}" dt="2025-10-07T13:22:26.576" v="71" actId="20577"/>
-          <ac:spMkLst>
-            <pc:docMk/>
-            <pc:sldMk cId="1611218844" sldId="1664"/>
-            <ac:spMk id="3" creationId="{53C7CEFC-ED22-BD54-F3AC-B4E2B8578D8B}"/>
-          </ac:spMkLst>
-        </pc:spChg>
-        <pc:spChg chg="mod">
-          <ac:chgData name="Andrew Turner" userId="9b60647a-c825-4266-aafa-670849c64782" providerId="ADAL" clId="{292526B5-234E-5EAA-AFB8-0412B8CA4453}" dt="2025-10-07T13:21:46.284" v="32" actId="692"/>
-          <ac:spMkLst>
-            <pc:docMk/>
-            <pc:sldMk cId="1611218844" sldId="1664"/>
-            <ac:spMk id="8" creationId="{4C78B08C-8218-E80E-49D3-EC918CA4BD4A}"/>
-          </ac:spMkLst>
-        </pc:spChg>
-        <pc:spChg chg="mod">
-          <ac:chgData name="Andrew Turner" userId="9b60647a-c825-4266-aafa-670849c64782" providerId="ADAL" clId="{292526B5-234E-5EAA-AFB8-0412B8CA4453}" dt="2025-10-07T13:21:57.815" v="33" actId="207"/>
-          <ac:spMkLst>
-            <pc:docMk/>
-            <pc:sldMk cId="1611218844" sldId="1664"/>
-            <ac:spMk id="10" creationId="{99D47B0F-1F4D-5D5F-3E84-FABFC561D6D0}"/>
-          </ac:spMkLst>
-        </pc:spChg>
-        <pc:spChg chg="mod">
-          <ac:chgData name="Andrew Turner" userId="9b60647a-c825-4266-aafa-670849c64782" providerId="ADAL" clId="{292526B5-234E-5EAA-AFB8-0412B8CA4453}" dt="2025-10-07T13:21:10.167" v="27" actId="207"/>
-          <ac:spMkLst>
-            <pc:docMk/>
-            <pc:sldMk cId="1611218844" sldId="1664"/>
-            <ac:spMk id="11" creationId="{5F0D419B-BDDE-1604-ED94-D7D91EAC94A0}"/>
-          </ac:spMkLst>
-        </pc:spChg>
-        <pc:spChg chg="mod">
-          <ac:chgData name="Andrew Turner" userId="9b60647a-c825-4266-aafa-670849c64782" providerId="ADAL" clId="{292526B5-234E-5EAA-AFB8-0412B8CA4453}" dt="2025-10-07T13:21:15.780" v="28" actId="207"/>
-          <ac:spMkLst>
-            <pc:docMk/>
-            <pc:sldMk cId="1611218844" sldId="1664"/>
-            <ac:spMk id="13" creationId="{C594A5FF-D053-6487-027A-24303E5D0DD0}"/>
-          </ac:spMkLst>
-        </pc:spChg>
-        <pc:cxnChg chg="mod">
-          <ac:chgData name="Andrew Turner" userId="9b60647a-c825-4266-aafa-670849c64782" providerId="ADAL" clId="{292526B5-234E-5EAA-AFB8-0412B8CA4453}" dt="2025-10-07T13:21:30.935" v="30" actId="692"/>
-          <ac:cxnSpMkLst>
-            <pc:docMk/>
-            <pc:sldMk cId="1611218844" sldId="1664"/>
-            <ac:cxnSpMk id="15" creationId="{5427A9D3-28EC-71EB-746B-073AE714C62B}"/>
-          </ac:cxnSpMkLst>
-        </pc:cxnChg>
-        <pc:cxnChg chg="mod">
-          <ac:chgData name="Andrew Turner" userId="9b60647a-c825-4266-aafa-670849c64782" providerId="ADAL" clId="{292526B5-234E-5EAA-AFB8-0412B8CA4453}" dt="2025-10-07T13:21:24.768" v="29" actId="692"/>
-          <ac:cxnSpMkLst>
-            <pc:docMk/>
-            <pc:sldMk cId="1611218844" sldId="1664"/>
-            <ac:cxnSpMk id="16" creationId="{2E155AD3-7D8E-9F4F-5D80-8E3187B28208}"/>
-          </ac:cxnSpMkLst>
-        </pc:cxnChg>
-        <pc:cxnChg chg="mod">
-          <ac:chgData name="Andrew Turner" userId="9b60647a-c825-4266-aafa-670849c64782" providerId="ADAL" clId="{292526B5-234E-5EAA-AFB8-0412B8CA4453}" dt="2025-10-07T13:21:36.104" v="31" actId="692"/>
-          <ac:cxnSpMkLst>
-            <pc:docMk/>
-            <pc:sldMk cId="1611218844" sldId="1664"/>
-            <ac:cxnSpMk id="17" creationId="{39496724-A57B-1146-4099-007E64FE9D44}"/>
-          </ac:cxnSpMkLst>
-        </pc:cxnChg>
-      </pc:sldChg>
-      <pc:sldChg chg="add">
-        <pc:chgData name="Andrew Turner" userId="9b60647a-c825-4266-aafa-670849c64782" providerId="ADAL" clId="{292526B5-234E-5EAA-AFB8-0412B8CA4453}" dt="2025-10-07T13:20:18.964" v="21"/>
-        <pc:sldMkLst>
-          <pc:docMk/>
-          <pc:sldMk cId="1096360323" sldId="1684"/>
-        </pc:sldMkLst>
-      </pc:sldChg>
-      <pc:sldChg chg="addSp modSp new mod">
-        <pc:chgData name="Andrew Turner" userId="9b60647a-c825-4266-aafa-670849c64782" providerId="ADAL" clId="{292526B5-234E-5EAA-AFB8-0412B8CA4453}" dt="2025-10-07T13:24:07.662" v="106" actId="14100"/>
-        <pc:sldMkLst>
-          <pc:docMk/>
-          <pc:sldMk cId="1126882526" sldId="1685"/>
-        </pc:sldMkLst>
-        <pc:spChg chg="mod">
-          <ac:chgData name="Andrew Turner" userId="9b60647a-c825-4266-aafa-670849c64782" providerId="ADAL" clId="{292526B5-234E-5EAA-AFB8-0412B8CA4453}" dt="2025-10-07T13:23:12.817" v="84" actId="20577"/>
-          <ac:spMkLst>
-            <pc:docMk/>
-            <pc:sldMk cId="1126882526" sldId="1685"/>
-            <ac:spMk id="2" creationId="{F93F3CC0-D8E1-54AF-A71D-6B5F9D62F952}"/>
-          </ac:spMkLst>
-        </pc:spChg>
-        <pc:spChg chg="mod">
-          <ac:chgData name="Andrew Turner" userId="9b60647a-c825-4266-aafa-670849c64782" providerId="ADAL" clId="{292526B5-234E-5EAA-AFB8-0412B8CA4453}" dt="2025-10-07T13:24:07.662" v="106" actId="14100"/>
-          <ac:spMkLst>
-            <pc:docMk/>
-            <pc:sldMk cId="1126882526" sldId="1685"/>
-            <ac:spMk id="3" creationId="{A0E92289-F23D-47E6-6305-4F71A4F96F62}"/>
-          </ac:spMkLst>
-        </pc:spChg>
-        <pc:spChg chg="add mod">
-          <ac:chgData name="Andrew Turner" userId="9b60647a-c825-4266-aafa-670849c64782" providerId="ADAL" clId="{292526B5-234E-5EAA-AFB8-0412B8CA4453}" dt="2025-10-07T13:23:40.412" v="99" actId="20577"/>
-          <ac:spMkLst>
-            <pc:docMk/>
-            <pc:sldMk cId="1126882526" sldId="1685"/>
-            <ac:spMk id="4" creationId="{8A95C691-2041-ABFB-7742-A1FE414FF8D7}"/>
-          </ac:spMkLst>
-        </pc:spChg>
-        <pc:spChg chg="add mod">
-          <ac:chgData name="Andrew Turner" userId="9b60647a-c825-4266-aafa-670849c64782" providerId="ADAL" clId="{292526B5-234E-5EAA-AFB8-0412B8CA4453}" dt="2025-10-07T13:24:02.456" v="104" actId="20577"/>
-          <ac:spMkLst>
-            <pc:docMk/>
-            <pc:sldMk cId="1126882526" sldId="1685"/>
-            <ac:spMk id="5" creationId="{11954015-84E1-79C2-6144-FE69DA6CBB83}"/>
-          </ac:spMkLst>
-        </pc:spChg>
-      </pc:sldChg>
-      <pc:sldMasterChg chg="setBg modSldLayout">
-        <pc:chgData name="Andrew Turner" userId="9b60647a-c825-4266-aafa-670849c64782" providerId="ADAL" clId="{292526B5-234E-5EAA-AFB8-0412B8CA4453}" dt="2025-10-07T13:19:01.146" v="15"/>
-        <pc:sldMasterMkLst>
-          <pc:docMk/>
-          <pc:sldMasterMk cId="2674214099" sldId="2147483648"/>
-        </pc:sldMasterMkLst>
-        <pc:sldLayoutChg chg="setBg">
-          <pc:chgData name="Andrew Turner" userId="9b60647a-c825-4266-aafa-670849c64782" providerId="ADAL" clId="{292526B5-234E-5EAA-AFB8-0412B8CA4453}" dt="2025-10-07T13:19:01.146" v="15"/>
-          <pc:sldLayoutMkLst>
-            <pc:docMk/>
-            <pc:sldMasterMk cId="2674214099" sldId="2147483648"/>
-            <pc:sldLayoutMk cId="2903308332" sldId="2147483649"/>
-          </pc:sldLayoutMkLst>
-        </pc:sldLayoutChg>
-        <pc:sldLayoutChg chg="setBg">
-          <pc:chgData name="Andrew Turner" userId="9b60647a-c825-4266-aafa-670849c64782" providerId="ADAL" clId="{292526B5-234E-5EAA-AFB8-0412B8CA4453}" dt="2025-10-07T13:19:01.146" v="15"/>
-          <pc:sldLayoutMkLst>
-            <pc:docMk/>
-            <pc:sldMasterMk cId="2674214099" sldId="2147483648"/>
-            <pc:sldLayoutMk cId="441733491" sldId="2147483650"/>
-          </pc:sldLayoutMkLst>
-        </pc:sldLayoutChg>
-        <pc:sldLayoutChg chg="setBg">
-          <pc:chgData name="Andrew Turner" userId="9b60647a-c825-4266-aafa-670849c64782" providerId="ADAL" clId="{292526B5-234E-5EAA-AFB8-0412B8CA4453}" dt="2025-10-07T13:19:01.146" v="15"/>
-          <pc:sldLayoutMkLst>
-            <pc:docMk/>
-            <pc:sldMasterMk cId="2674214099" sldId="2147483648"/>
-            <pc:sldLayoutMk cId="422556004" sldId="2147483651"/>
-          </pc:sldLayoutMkLst>
-        </pc:sldLayoutChg>
-        <pc:sldLayoutChg chg="setBg">
-          <pc:chgData name="Andrew Turner" userId="9b60647a-c825-4266-aafa-670849c64782" providerId="ADAL" clId="{292526B5-234E-5EAA-AFB8-0412B8CA4453}" dt="2025-10-07T13:19:01.146" v="15"/>
-          <pc:sldLayoutMkLst>
-            <pc:docMk/>
-            <pc:sldMasterMk cId="2674214099" sldId="2147483648"/>
-            <pc:sldLayoutMk cId="1440641589" sldId="2147483652"/>
-          </pc:sldLayoutMkLst>
-        </pc:sldLayoutChg>
-        <pc:sldLayoutChg chg="setBg">
-          <pc:chgData name="Andrew Turner" userId="9b60647a-c825-4266-aafa-670849c64782" providerId="ADAL" clId="{292526B5-234E-5EAA-AFB8-0412B8CA4453}" dt="2025-10-07T13:19:01.146" v="15"/>
-          <pc:sldLayoutMkLst>
-            <pc:docMk/>
-            <pc:sldMasterMk cId="2674214099" sldId="2147483648"/>
-            <pc:sldLayoutMk cId="1210976889" sldId="2147483653"/>
-          </pc:sldLayoutMkLst>
-        </pc:sldLayoutChg>
-        <pc:sldLayoutChg chg="setBg">
-          <pc:chgData name="Andrew Turner" userId="9b60647a-c825-4266-aafa-670849c64782" providerId="ADAL" clId="{292526B5-234E-5EAA-AFB8-0412B8CA4453}" dt="2025-10-07T13:19:01.146" v="15"/>
-          <pc:sldLayoutMkLst>
-            <pc:docMk/>
-            <pc:sldMasterMk cId="2674214099" sldId="2147483648"/>
-            <pc:sldLayoutMk cId="3181193731" sldId="2147483654"/>
-          </pc:sldLayoutMkLst>
-        </pc:sldLayoutChg>
-        <pc:sldLayoutChg chg="setBg">
-          <pc:chgData name="Andrew Turner" userId="9b60647a-c825-4266-aafa-670849c64782" providerId="ADAL" clId="{292526B5-234E-5EAA-AFB8-0412B8CA4453}" dt="2025-10-07T13:19:01.146" v="15"/>
-          <pc:sldLayoutMkLst>
-            <pc:docMk/>
-            <pc:sldMasterMk cId="2674214099" sldId="2147483648"/>
-            <pc:sldLayoutMk cId="784563606" sldId="2147483655"/>
-          </pc:sldLayoutMkLst>
-        </pc:sldLayoutChg>
-        <pc:sldLayoutChg chg="setBg">
-          <pc:chgData name="Andrew Turner" userId="9b60647a-c825-4266-aafa-670849c64782" providerId="ADAL" clId="{292526B5-234E-5EAA-AFB8-0412B8CA4453}" dt="2025-10-07T13:19:01.146" v="15"/>
-          <pc:sldLayoutMkLst>
-            <pc:docMk/>
-            <pc:sldMasterMk cId="2674214099" sldId="2147483648"/>
-            <pc:sldLayoutMk cId="3075172664" sldId="2147483656"/>
-          </pc:sldLayoutMkLst>
-        </pc:sldLayoutChg>
-        <pc:sldLayoutChg chg="setBg">
-          <pc:chgData name="Andrew Turner" userId="9b60647a-c825-4266-aafa-670849c64782" providerId="ADAL" clId="{292526B5-234E-5EAA-AFB8-0412B8CA4453}" dt="2025-10-07T13:19:01.146" v="15"/>
-          <pc:sldLayoutMkLst>
-            <pc:docMk/>
-            <pc:sldMasterMk cId="2674214099" sldId="2147483648"/>
-            <pc:sldLayoutMk cId="984828245" sldId="2147483657"/>
-          </pc:sldLayoutMkLst>
-        </pc:sldLayoutChg>
-        <pc:sldLayoutChg chg="setBg">
-          <pc:chgData name="Andrew Turner" userId="9b60647a-c825-4266-aafa-670849c64782" providerId="ADAL" clId="{292526B5-234E-5EAA-AFB8-0412B8CA4453}" dt="2025-10-07T13:19:01.146" v="15"/>
-          <pc:sldLayoutMkLst>
-            <pc:docMk/>
-            <pc:sldMasterMk cId="2674214099" sldId="2147483648"/>
-            <pc:sldLayoutMk cId="956278031" sldId="2147483658"/>
-          </pc:sldLayoutMkLst>
-        </pc:sldLayoutChg>
-        <pc:sldLayoutChg chg="setBg">
-          <pc:chgData name="Andrew Turner" userId="9b60647a-c825-4266-aafa-670849c64782" providerId="ADAL" clId="{292526B5-234E-5EAA-AFB8-0412B8CA4453}" dt="2025-10-07T13:19:01.146" v="15"/>
-          <pc:sldLayoutMkLst>
-            <pc:docMk/>
-            <pc:sldMasterMk cId="2674214099" sldId="2147483648"/>
-            <pc:sldLayoutMk cId="1409150725" sldId="2147483659"/>
-          </pc:sldLayoutMkLst>
-        </pc:sldLayoutChg>
-      </pc:sldMasterChg>
     </pc:docChg>
   </pc:docChgLst>
 </pc:chgInfo>
+</file>
+
+<file path=ppt/notesMasters/notesMaster1.xml><?xml version="1.0" encoding="utf-8"?>
+<p:notesMaster xmlns:a="http://schemas.openxmlformats.org/drawingml/2006/main" xmlns:r="http://schemas.openxmlformats.org/officeDocument/2006/relationships" xmlns:p="http://schemas.openxmlformats.org/presentationml/2006/main">
+  <p:cSld>
+    <p:bg>
+      <p:bgRef idx="1001">
+        <a:schemeClr val="bg1"/>
+      </p:bgRef>
+    </p:bg>
+    <p:spTree>
+      <p:nvGrpSpPr>
+        <p:cNvPr id="1" name=""/>
+        <p:cNvGrpSpPr/>
+        <p:nvPr/>
+      </p:nvGrpSpPr>
+      <p:grpSpPr>
+        <a:xfrm>
+          <a:off x="0" y="0"/>
+          <a:ext cx="0" cy="0"/>
+          <a:chOff x="0" y="0"/>
+          <a:chExt cx="0" cy="0"/>
+        </a:xfrm>
+      </p:grpSpPr>
+      <p:sp>
+        <p:nvSpPr>
+          <p:cNvPr id="2" name="Header Placeholder 1"/>
+          <p:cNvSpPr>
+            <a:spLocks noGrp="1"/>
+          </p:cNvSpPr>
+          <p:nvPr>
+            <p:ph type="hdr" sz="quarter"/>
+          </p:nvPr>
+        </p:nvSpPr>
+        <p:spPr>
+          <a:xfrm>
+            <a:off x="0" y="0"/>
+            <a:ext cx="2971800" cy="458788"/>
+          </a:xfrm>
+          <a:prstGeom prst="rect">
+            <a:avLst/>
+          </a:prstGeom>
+        </p:spPr>
+        <p:txBody>
+          <a:bodyPr vert="horz" lIns="91440" tIns="45720" rIns="91440" bIns="45720" rtlCol="0"/>
+          <a:lstStyle>
+            <a:lvl1pPr algn="l">
+              <a:defRPr sz="1200"/>
+            </a:lvl1pPr>
+          </a:lstStyle>
+          <a:p>
+            <a:endParaRPr lang="en-GB"/>
+          </a:p>
+        </p:txBody>
+      </p:sp>
+      <p:sp>
+        <p:nvSpPr>
+          <p:cNvPr id="3" name="Date Placeholder 2"/>
+          <p:cNvSpPr>
+            <a:spLocks noGrp="1"/>
+          </p:cNvSpPr>
+          <p:nvPr>
+            <p:ph type="dt" idx="1"/>
+          </p:nvPr>
+        </p:nvSpPr>
+        <p:spPr>
+          <a:xfrm>
+            <a:off x="3884613" y="0"/>
+            <a:ext cx="2971800" cy="458788"/>
+          </a:xfrm>
+          <a:prstGeom prst="rect">
+            <a:avLst/>
+          </a:prstGeom>
+        </p:spPr>
+        <p:txBody>
+          <a:bodyPr vert="horz" lIns="91440" tIns="45720" rIns="91440" bIns="45720" rtlCol="0"/>
+          <a:lstStyle>
+            <a:lvl1pPr algn="r">
+              <a:defRPr sz="1200"/>
+            </a:lvl1pPr>
+          </a:lstStyle>
+          <a:p>
+            <a:fld id="{E23FCC8D-1DAE-3546-9256-E10EA26336EA}" type="datetimeFigureOut">
+              <a:rPr lang="en-GB" smtClean="0"/>
+              <a:t>01/10/2026</a:t>
+            </a:fld>
+            <a:endParaRPr lang="en-GB"/>
+          </a:p>
+        </p:txBody>
+      </p:sp>
+      <p:sp>
+        <p:nvSpPr>
+          <p:cNvPr id="4" name="Slide Image Placeholder 3"/>
+          <p:cNvSpPr>
+            <a:spLocks noGrp="1" noRot="1" noChangeAspect="1"/>
+          </p:cNvSpPr>
+          <p:nvPr>
+            <p:ph type="sldImg" idx="2"/>
+          </p:nvPr>
+        </p:nvSpPr>
+        <p:spPr>
+          <a:xfrm>
+            <a:off x="685800" y="1143000"/>
+            <a:ext cx="5486400" cy="3086100"/>
+          </a:xfrm>
+          <a:prstGeom prst="rect">
+            <a:avLst/>
+          </a:prstGeom>
+          <a:noFill/>
+          <a:ln w="12700">
+            <a:solidFill>
+              <a:prstClr val="black"/>
+            </a:solidFill>
+          </a:ln>
+        </p:spPr>
+        <p:txBody>
+          <a:bodyPr vert="horz" lIns="91440" tIns="45720" rIns="91440" bIns="45720" rtlCol="0" anchor="ctr"/>
+          <a:lstStyle/>
+          <a:p>
+            <a:endParaRPr lang="en-GB"/>
+          </a:p>
+        </p:txBody>
+      </p:sp>
+      <p:sp>
+        <p:nvSpPr>
+          <p:cNvPr id="5" name="Notes Placeholder 4"/>
+          <p:cNvSpPr>
+            <a:spLocks noGrp="1"/>
+          </p:cNvSpPr>
+          <p:nvPr>
+            <p:ph type="body" sz="quarter" idx="3"/>
+          </p:nvPr>
+        </p:nvSpPr>
+        <p:spPr>
+          <a:xfrm>
+            <a:off x="685800" y="4400550"/>
+            <a:ext cx="5486400" cy="3600450"/>
+          </a:xfrm>
+          <a:prstGeom prst="rect">
+            <a:avLst/>
+          </a:prstGeom>
+        </p:spPr>
+        <p:txBody>
+          <a:bodyPr vert="horz" lIns="91440" tIns="45720" rIns="91440" bIns="45720" rtlCol="0"/>
+          <a:lstStyle/>
+          <a:p>
+            <a:pPr lvl="0"/>
+            <a:r>
+              <a:rPr lang="en-GB"/>
+              <a:t>Click to edit Master text styles</a:t>
+            </a:r>
+          </a:p>
+          <a:p>
+            <a:pPr lvl="1"/>
+            <a:r>
+              <a:rPr lang="en-GB"/>
+              <a:t>Second level</a:t>
+            </a:r>
+          </a:p>
+          <a:p>
+            <a:pPr lvl="2"/>
+            <a:r>
+              <a:rPr lang="en-GB"/>
+              <a:t>Third level</a:t>
+            </a:r>
+          </a:p>
+          <a:p>
+            <a:pPr lvl="3"/>
+            <a:r>
+              <a:rPr lang="en-GB"/>
+              <a:t>Fourth level</a:t>
+            </a:r>
+          </a:p>
+          <a:p>
+            <a:pPr lvl="4"/>
+            <a:r>
+              <a:rPr lang="en-GB"/>
+              <a:t>Fifth level</a:t>
+            </a:r>
+          </a:p>
+        </p:txBody>
+      </p:sp>
+      <p:sp>
+        <p:nvSpPr>
+          <p:cNvPr id="6" name="Footer Placeholder 5"/>
+          <p:cNvSpPr>
+            <a:spLocks noGrp="1"/>
+          </p:cNvSpPr>
+          <p:nvPr>
+            <p:ph type="ftr" sz="quarter" idx="4"/>
+          </p:nvPr>
+        </p:nvSpPr>
+        <p:spPr>
+          <a:xfrm>
+            <a:off x="0" y="8685213"/>
+            <a:ext cx="2971800" cy="458787"/>
+          </a:xfrm>
+          <a:prstGeom prst="rect">
+            <a:avLst/>
+          </a:prstGeom>
+        </p:spPr>
+        <p:txBody>
+          <a:bodyPr vert="horz" lIns="91440" tIns="45720" rIns="91440" bIns="45720" rtlCol="0" anchor="b"/>
+          <a:lstStyle>
+            <a:lvl1pPr algn="l">
+              <a:defRPr sz="1200"/>
+            </a:lvl1pPr>
+          </a:lstStyle>
+          <a:p>
+            <a:endParaRPr lang="en-GB"/>
+          </a:p>
+        </p:txBody>
+      </p:sp>
+      <p:sp>
+        <p:nvSpPr>
+          <p:cNvPr id="7" name="Slide Number Placeholder 6"/>
+          <p:cNvSpPr>
+            <a:spLocks noGrp="1"/>
+          </p:cNvSpPr>
+          <p:nvPr>
+            <p:ph type="sldNum" sz="quarter" idx="5"/>
+          </p:nvPr>
+        </p:nvSpPr>
+        <p:spPr>
+          <a:xfrm>
+            <a:off x="3884613" y="8685213"/>
+            <a:ext cx="2971800" cy="458787"/>
+          </a:xfrm>
+          <a:prstGeom prst="rect">
+            <a:avLst/>
+          </a:prstGeom>
+        </p:spPr>
+        <p:txBody>
+          <a:bodyPr vert="horz" lIns="91440" tIns="45720" rIns="91440" bIns="45720" rtlCol="0" anchor="b"/>
+          <a:lstStyle>
+            <a:lvl1pPr algn="r">
+              <a:defRPr sz="1200"/>
+            </a:lvl1pPr>
+          </a:lstStyle>
+          <a:p>
+            <a:fld id="{600FDE4F-D838-504B-93E4-243C4C53D4EB}" type="slidenum">
+              <a:rPr lang="en-GB" smtClean="0"/>
+              <a:t>‹#›</a:t>
+            </a:fld>
+            <a:endParaRPr lang="en-GB"/>
+          </a:p>
+        </p:txBody>
+      </p:sp>
+    </p:spTree>
+    <p:extLst>
+      <p:ext uri="{BB962C8B-B14F-4D97-AF65-F5344CB8AC3E}">
+        <p14:creationId xmlns:p14="http://schemas.microsoft.com/office/powerpoint/2010/main" val="1944693963"/>
+      </p:ext>
+    </p:extLst>
+  </p:cSld>
+  <p:clrMap bg1="lt1" tx1="dk1" bg2="lt2" tx2="dk2" accent1="accent1" accent2="accent2" accent3="accent3" accent4="accent4" accent5="accent5" accent6="accent6" hlink="hlink" folHlink="folHlink"/>
+  <p:notesStyle>
+    <a:lvl1pPr marL="0" algn="l" defTabSz="914400" rtl="0" eaLnBrk="1" latinLnBrk="0" hangingPunct="1">
+      <a:defRPr sz="1200" kern="1200">
+        <a:solidFill>
+          <a:schemeClr val="tx1"/>
+        </a:solidFill>
+        <a:latin typeface="+mn-lt"/>
+        <a:ea typeface="+mn-ea"/>
+        <a:cs typeface="+mn-cs"/>
+      </a:defRPr>
+    </a:lvl1pPr>
+    <a:lvl2pPr marL="457200" algn="l" defTabSz="914400" rtl="0" eaLnBrk="1" latinLnBrk="0" hangingPunct="1">
+      <a:defRPr sz="1200" kern="1200">
+        <a:solidFill>
+          <a:schemeClr val="tx1"/>
+        </a:solidFill>
+        <a:latin typeface="+mn-lt"/>
+        <a:ea typeface="+mn-ea"/>
+        <a:cs typeface="+mn-cs"/>
+      </a:defRPr>
+    </a:lvl2pPr>
+    <a:lvl3pPr marL="914400" algn="l" defTabSz="914400" rtl="0" eaLnBrk="1" latinLnBrk="0" hangingPunct="1">
+      <a:defRPr sz="1200" kern="1200">
+        <a:solidFill>
+          <a:schemeClr val="tx1"/>
+        </a:solidFill>
+        <a:latin typeface="+mn-lt"/>
+        <a:ea typeface="+mn-ea"/>
+        <a:cs typeface="+mn-cs"/>
+      </a:defRPr>
+    </a:lvl3pPr>
+    <a:lvl4pPr marL="1371600" algn="l" defTabSz="914400" rtl="0" eaLnBrk="1" latinLnBrk="0" hangingPunct="1">
+      <a:defRPr sz="1200" kern="1200">
+        <a:solidFill>
+          <a:schemeClr val="tx1"/>
+        </a:solidFill>
+        <a:latin typeface="+mn-lt"/>
+        <a:ea typeface="+mn-ea"/>
+        <a:cs typeface="+mn-cs"/>
+      </a:defRPr>
+    </a:lvl4pPr>
+    <a:lvl5pPr marL="1828800" algn="l" defTabSz="914400" rtl="0" eaLnBrk="1" latinLnBrk="0" hangingPunct="1">
+      <a:defRPr sz="1200" kern="1200">
+        <a:solidFill>
+          <a:schemeClr val="tx1"/>
+        </a:solidFill>
+        <a:latin typeface="+mn-lt"/>
+        <a:ea typeface="+mn-ea"/>
+        <a:cs typeface="+mn-cs"/>
+      </a:defRPr>
+    </a:lvl5pPr>
+    <a:lvl6pPr marL="2286000" algn="l" defTabSz="914400" rtl="0" eaLnBrk="1" latinLnBrk="0" hangingPunct="1">
+      <a:defRPr sz="1200" kern="1200">
+        <a:solidFill>
+          <a:schemeClr val="tx1"/>
+        </a:solidFill>
+        <a:latin typeface="+mn-lt"/>
+        <a:ea typeface="+mn-ea"/>
+        <a:cs typeface="+mn-cs"/>
+      </a:defRPr>
+    </a:lvl6pPr>
+    <a:lvl7pPr marL="2743200" algn="l" defTabSz="914400" rtl="0" eaLnBrk="1" latinLnBrk="0" hangingPunct="1">
+      <a:defRPr sz="1200" kern="1200">
+        <a:solidFill>
+          <a:schemeClr val="tx1"/>
+        </a:solidFill>
+        <a:latin typeface="+mn-lt"/>
+        <a:ea typeface="+mn-ea"/>
+        <a:cs typeface="+mn-cs"/>
+      </a:defRPr>
+    </a:lvl7pPr>
+    <a:lvl8pPr marL="3200400" algn="l" defTabSz="914400" rtl="0" eaLnBrk="1" latinLnBrk="0" hangingPunct="1">
+      <a:defRPr sz="1200" kern="1200">
+        <a:solidFill>
+          <a:schemeClr val="tx1"/>
+        </a:solidFill>
+        <a:latin typeface="+mn-lt"/>
+        <a:ea typeface="+mn-ea"/>
+        <a:cs typeface="+mn-cs"/>
+      </a:defRPr>
+    </a:lvl8pPr>
+    <a:lvl9pPr marL="3657600" algn="l" defTabSz="914400" rtl="0" eaLnBrk="1" latinLnBrk="0" hangingPunct="1">
+      <a:defRPr sz="1200" kern="1200">
+        <a:solidFill>
+          <a:schemeClr val="tx1"/>
+        </a:solidFill>
+        <a:latin typeface="+mn-lt"/>
+        <a:ea typeface="+mn-ea"/>
+        <a:cs typeface="+mn-cs"/>
+      </a:defRPr>
+    </a:lvl9pPr>
+  </p:notesStyle>
+</p:notesMaster>
+</file>
+
+<file path=ppt/notesSlides/notesSlide1.xml><?xml version="1.0" encoding="utf-8"?>
+<p:notes xmlns:a="http://schemas.openxmlformats.org/drawingml/2006/main" xmlns:r="http://schemas.openxmlformats.org/officeDocument/2006/relationships" xmlns:p="http://schemas.openxmlformats.org/presentationml/2006/main">
+  <p:cSld>
+    <p:spTree>
+      <p:nvGrpSpPr>
+        <p:cNvPr id="1" name=""/>
+        <p:cNvGrpSpPr/>
+        <p:nvPr/>
+      </p:nvGrpSpPr>
+      <p:grpSpPr>
+        <a:xfrm>
+          <a:off x="0" y="0"/>
+          <a:ext cx="0" cy="0"/>
+          <a:chOff x="0" y="0"/>
+          <a:chExt cx="0" cy="0"/>
+        </a:xfrm>
+      </p:grpSpPr>
+      <p:sp>
+        <p:nvSpPr>
+          <p:cNvPr id="2" name="Slide Image Placeholder 1"/>
+          <p:cNvSpPr>
+            <a:spLocks noGrp="1" noRot="1" noChangeAspect="1"/>
+          </p:cNvSpPr>
+          <p:nvPr>
+            <p:ph type="sldImg"/>
+          </p:nvPr>
+        </p:nvSpPr>
+        <p:spPr/>
+      </p:sp>
+      <p:sp>
+        <p:nvSpPr>
+          <p:cNvPr id="3" name="Notes Placeholder 2"/>
+          <p:cNvSpPr>
+            <a:spLocks noGrp="1"/>
+          </p:cNvSpPr>
+          <p:nvPr>
+            <p:ph type="body" idx="1"/>
+          </p:nvPr>
+        </p:nvSpPr>
+        <p:spPr/>
+        <p:txBody>
+          <a:bodyPr/>
+          <a:lstStyle/>
+          <a:p>
+            <a:r>
+              <a:rPr lang="en-GB" dirty="0"/>
+              <a:t>Many experts believe China’s emissions have now reached their peak and will continue to decrease</a:t>
+            </a:r>
+          </a:p>
+          <a:p>
+            <a:r>
+              <a:rPr lang="en-GB" dirty="0"/>
+              <a:t>Electricity generation from fossil fuels is rapidly decreasing almost everywhere</a:t>
+            </a:r>
+          </a:p>
+          <a:p>
+            <a:r>
+              <a:rPr lang="en-GB" dirty="0"/>
+              <a:t>Take up of electric vehicles (both commercial and private) is accelerating</a:t>
+            </a:r>
+          </a:p>
+          <a:p>
+            <a:pPr lvl="1"/>
+            <a:r>
+              <a:rPr lang="en-GB" dirty="0"/>
+              <a:t>97% of new cars bought in Norway last year were electric (25% in the UK)</a:t>
+            </a:r>
+          </a:p>
+          <a:p>
+            <a:endParaRPr lang="en-GB" dirty="0"/>
+          </a:p>
+        </p:txBody>
+      </p:sp>
+      <p:sp>
+        <p:nvSpPr>
+          <p:cNvPr id="4" name="Slide Number Placeholder 3"/>
+          <p:cNvSpPr>
+            <a:spLocks noGrp="1"/>
+          </p:cNvSpPr>
+          <p:nvPr>
+            <p:ph type="sldNum" sz="quarter" idx="5"/>
+          </p:nvPr>
+        </p:nvSpPr>
+        <p:spPr/>
+        <p:txBody>
+          <a:bodyPr/>
+          <a:lstStyle/>
+          <a:p>
+            <a:fld id="{B0620144-03AE-FA4B-9C5D-94994AD76B80}" type="slidenum">
+              <a:rPr lang="en-GB" smtClean="0"/>
+              <a:t>5</a:t>
+            </a:fld>
+            <a:endParaRPr lang="en-GB"/>
+          </a:p>
+        </p:txBody>
+      </p:sp>
+    </p:spTree>
+    <p:extLst>
+      <p:ext uri="{BB962C8B-B14F-4D97-AF65-F5344CB8AC3E}">
+        <p14:creationId xmlns:p14="http://schemas.microsoft.com/office/powerpoint/2010/main" val="3389143131"/>
+      </p:ext>
+    </p:extLst>
+  </p:cSld>
+  <p:clrMapOvr>
+    <a:masterClrMapping/>
+  </p:clrMapOvr>
+</p:notes>
 </file>
 
 <file path=ppt/slideLayouts/slideLayout1.xml><?xml version="1.0" encoding="utf-8"?>
@@ -741,7 +761,7 @@
           <a:p>
             <a:fld id="{5C71754A-319A-8245-9AA4-B46082C5A76D}" type="datetimeFigureOut">
               <a:rPr lang="en-GB" smtClean="0"/>
-              <a:t>07/10/2025</a:t>
+              <a:t>01/10/2026</a:t>
             </a:fld>
             <a:endParaRPr lang="en-GB"/>
           </a:p>
@@ -939,7 +959,7 @@
           <a:p>
             <a:fld id="{5C71754A-319A-8245-9AA4-B46082C5A76D}" type="datetimeFigureOut">
               <a:rPr lang="en-GB" smtClean="0"/>
-              <a:t>07/10/2025</a:t>
+              <a:t>01/10/2026</a:t>
             </a:fld>
             <a:endParaRPr lang="en-GB"/>
           </a:p>
@@ -1147,7 +1167,7 @@
           <a:p>
             <a:fld id="{5C71754A-319A-8245-9AA4-B46082C5A76D}" type="datetimeFigureOut">
               <a:rPr lang="en-GB" smtClean="0"/>
-              <a:t>07/10/2025</a:t>
+              <a:t>01/10/2026</a:t>
             </a:fld>
             <a:endParaRPr lang="en-GB"/>
           </a:p>
@@ -1345,7 +1365,7 @@
           <a:p>
             <a:fld id="{5C71754A-319A-8245-9AA4-B46082C5A76D}" type="datetimeFigureOut">
               <a:rPr lang="en-GB" smtClean="0"/>
-              <a:t>07/10/2025</a:t>
+              <a:t>01/10/2026</a:t>
             </a:fld>
             <a:endParaRPr lang="en-GB"/>
           </a:p>
@@ -1620,7 +1640,7 @@
           <a:p>
             <a:fld id="{5C71754A-319A-8245-9AA4-B46082C5A76D}" type="datetimeFigureOut">
               <a:rPr lang="en-GB" smtClean="0"/>
-              <a:t>07/10/2025</a:t>
+              <a:t>01/10/2026</a:t>
             </a:fld>
             <a:endParaRPr lang="en-GB"/>
           </a:p>
@@ -1885,7 +1905,7 @@
           <a:p>
             <a:fld id="{5C71754A-319A-8245-9AA4-B46082C5A76D}" type="datetimeFigureOut">
               <a:rPr lang="en-GB" smtClean="0"/>
-              <a:t>07/10/2025</a:t>
+              <a:t>01/10/2026</a:t>
             </a:fld>
             <a:endParaRPr lang="en-GB"/>
           </a:p>
@@ -2297,7 +2317,7 @@
           <a:p>
             <a:fld id="{5C71754A-319A-8245-9AA4-B46082C5A76D}" type="datetimeFigureOut">
               <a:rPr lang="en-GB" smtClean="0"/>
-              <a:t>07/10/2025</a:t>
+              <a:t>01/10/2026</a:t>
             </a:fld>
             <a:endParaRPr lang="en-GB"/>
           </a:p>
@@ -2438,7 +2458,7 @@
           <a:p>
             <a:fld id="{5C71754A-319A-8245-9AA4-B46082C5A76D}" type="datetimeFigureOut">
               <a:rPr lang="en-GB" smtClean="0"/>
-              <a:t>07/10/2025</a:t>
+              <a:t>01/10/2026</a:t>
             </a:fld>
             <a:endParaRPr lang="en-GB"/>
           </a:p>
@@ -2551,7 +2571,7 @@
           <a:p>
             <a:fld id="{5C71754A-319A-8245-9AA4-B46082C5A76D}" type="datetimeFigureOut">
               <a:rPr lang="en-GB" smtClean="0"/>
-              <a:t>07/10/2025</a:t>
+              <a:t>01/10/2026</a:t>
             </a:fld>
             <a:endParaRPr lang="en-GB"/>
           </a:p>
@@ -2862,7 +2882,7 @@
           <a:p>
             <a:fld id="{5C71754A-319A-8245-9AA4-B46082C5A76D}" type="datetimeFigureOut">
               <a:rPr lang="en-GB" smtClean="0"/>
-              <a:t>07/10/2025</a:t>
+              <a:t>01/10/2026</a:t>
             </a:fld>
             <a:endParaRPr lang="en-GB"/>
           </a:p>
@@ -3150,7 +3170,7 @@
           <a:p>
             <a:fld id="{5C71754A-319A-8245-9AA4-B46082C5A76D}" type="datetimeFigureOut">
               <a:rPr lang="en-GB" smtClean="0"/>
-              <a:t>07/10/2025</a:t>
+              <a:t>01/10/2026</a:t>
             </a:fld>
             <a:endParaRPr lang="en-GB"/>
           </a:p>
@@ -3394,7 +3414,7 @@
           <a:p>
             <a:fld id="{5C71754A-319A-8245-9AA4-B46082C5A76D}" type="datetimeFigureOut">
               <a:rPr lang="en-GB" smtClean="0"/>
-              <a:t>07/10/2025</a:t>
+              <a:t>01/10/2026</a:t>
             </a:fld>
             <a:endParaRPr lang="en-GB"/>
           </a:p>
@@ -3902,6 +3922,314 @@
           <p:cNvPr id="2" name="Title 1">
             <a:extLst>
               <a:ext uri="{FF2B5EF4-FFF2-40B4-BE49-F238E27FC236}">
+                <a16:creationId xmlns:a16="http://schemas.microsoft.com/office/drawing/2014/main" id="{534421AB-2E7C-0C8C-8B80-12FBE0BFF8D1}"/>
+              </a:ext>
+            </a:extLst>
+          </p:cNvPr>
+          <p:cNvSpPr>
+            <a:spLocks noGrp="1"/>
+          </p:cNvSpPr>
+          <p:nvPr>
+            <p:ph type="title"/>
+          </p:nvPr>
+        </p:nvSpPr>
+        <p:spPr/>
+        <p:txBody>
+          <a:bodyPr/>
+          <a:lstStyle/>
+          <a:p>
+            <a:r>
+              <a:rPr lang="en-GB" dirty="0">
+                <a:solidFill>
+                  <a:schemeClr val="accent3"/>
+                </a:solidFill>
+              </a:rPr>
+              <a:t>Exercise: Emissions from your work</a:t>
+            </a:r>
+          </a:p>
+        </p:txBody>
+      </p:sp>
+      <p:sp>
+        <p:nvSpPr>
+          <p:cNvPr id="3" name="Content Placeholder 2">
+            <a:extLst>
+              <a:ext uri="{FF2B5EF4-FFF2-40B4-BE49-F238E27FC236}">
+                <a16:creationId xmlns:a16="http://schemas.microsoft.com/office/drawing/2014/main" id="{4D3BEC50-78D0-1BFE-3014-63A622CBED21}"/>
+              </a:ext>
+            </a:extLst>
+          </p:cNvPr>
+          <p:cNvSpPr>
+            <a:spLocks noGrp="1"/>
+          </p:cNvSpPr>
+          <p:nvPr>
+            <p:ph idx="1"/>
+          </p:nvPr>
+        </p:nvSpPr>
+        <p:spPr/>
+        <p:txBody>
+          <a:bodyPr/>
+          <a:lstStyle/>
+          <a:p>
+            <a:pPr marL="0" indent="0">
+              <a:buNone/>
+            </a:pPr>
+            <a:r>
+              <a:rPr lang="en-GB" dirty="0"/>
+              <a:t>Use of HPC will be only one part of your activities associated with your work and may not even be the largest source of carbon emissions.</a:t>
+            </a:r>
+          </a:p>
+          <a:p>
+            <a:pPr marL="0" indent="0">
+              <a:buNone/>
+            </a:pPr>
+            <a:endParaRPr lang="en-GB" dirty="0"/>
+          </a:p>
+          <a:p>
+            <a:r>
+              <a:rPr lang="en-GB" dirty="0"/>
+              <a:t>List sources of carbon emissions from your work activities other than via HPC systems</a:t>
+            </a:r>
+          </a:p>
+          <a:p>
+            <a:r>
+              <a:rPr lang="en-GB" dirty="0"/>
+              <a:t>Try to rank them in order of what you think the largest will be to the smallest</a:t>
+            </a:r>
+          </a:p>
+          <a:p>
+            <a:pPr marL="0" indent="0">
+              <a:buNone/>
+            </a:pPr>
+            <a:endParaRPr lang="en-GB" dirty="0"/>
+          </a:p>
+        </p:txBody>
+      </p:sp>
+    </p:spTree>
+    <p:extLst>
+      <p:ext uri="{BB962C8B-B14F-4D97-AF65-F5344CB8AC3E}">
+        <p14:creationId xmlns:p14="http://schemas.microsoft.com/office/powerpoint/2010/main" val="1336928419"/>
+      </p:ext>
+    </p:extLst>
+  </p:cSld>
+  <p:clrMapOvr>
+    <a:masterClrMapping/>
+  </p:clrMapOvr>
+</p:sld>
+</file>
+
+<file path=ppt/slides/slide11.xml><?xml version="1.0" encoding="utf-8"?>
+<p:sld xmlns:a="http://schemas.openxmlformats.org/drawingml/2006/main" xmlns:r="http://schemas.openxmlformats.org/officeDocument/2006/relationships" xmlns:p="http://schemas.openxmlformats.org/presentationml/2006/main">
+  <p:cSld>
+    <p:spTree>
+      <p:nvGrpSpPr>
+        <p:cNvPr id="1" name=""/>
+        <p:cNvGrpSpPr/>
+        <p:nvPr/>
+      </p:nvGrpSpPr>
+      <p:grpSpPr>
+        <a:xfrm>
+          <a:off x="0" y="0"/>
+          <a:ext cx="0" cy="0"/>
+          <a:chOff x="0" y="0"/>
+          <a:chExt cx="0" cy="0"/>
+        </a:xfrm>
+      </p:grpSpPr>
+      <p:sp>
+        <p:nvSpPr>
+          <p:cNvPr id="2" name="Title 1">
+            <a:extLst>
+              <a:ext uri="{FF2B5EF4-FFF2-40B4-BE49-F238E27FC236}">
+                <a16:creationId xmlns:a16="http://schemas.microsoft.com/office/drawing/2014/main" id="{A14A4F2D-67FE-A40B-38A1-FE15430A041C}"/>
+              </a:ext>
+            </a:extLst>
+          </p:cNvPr>
+          <p:cNvSpPr>
+            <a:spLocks noGrp="1"/>
+          </p:cNvSpPr>
+          <p:nvPr>
+            <p:ph type="title"/>
+          </p:nvPr>
+        </p:nvSpPr>
+        <p:spPr/>
+        <p:txBody>
+          <a:bodyPr/>
+          <a:lstStyle/>
+          <a:p>
+            <a:r>
+              <a:rPr lang="en-GB" dirty="0">
+                <a:solidFill>
+                  <a:schemeClr val="accent3">
+                    <a:lumMod val="75000"/>
+                  </a:schemeClr>
+                </a:solidFill>
+              </a:rPr>
+              <a:t>Solution</a:t>
+            </a:r>
+          </a:p>
+        </p:txBody>
+      </p:sp>
+      <p:sp>
+        <p:nvSpPr>
+          <p:cNvPr id="3" name="Content Placeholder 2">
+            <a:extLst>
+              <a:ext uri="{FF2B5EF4-FFF2-40B4-BE49-F238E27FC236}">
+                <a16:creationId xmlns:a16="http://schemas.microsoft.com/office/drawing/2014/main" id="{681A15F2-B311-C881-92C3-93622D9DC6C9}"/>
+              </a:ext>
+            </a:extLst>
+          </p:cNvPr>
+          <p:cNvSpPr>
+            <a:spLocks noGrp="1"/>
+          </p:cNvSpPr>
+          <p:nvPr>
+            <p:ph idx="1"/>
+          </p:nvPr>
+        </p:nvSpPr>
+        <p:spPr>
+          <a:xfrm>
+            <a:off x="838199" y="1494971"/>
+            <a:ext cx="10515601" cy="4997904"/>
+          </a:xfrm>
+        </p:spPr>
+        <p:txBody>
+          <a:bodyPr>
+            <a:normAutofit fontScale="62500" lnSpcReduction="20000"/>
+          </a:bodyPr>
+          <a:lstStyle/>
+          <a:p>
+            <a:pPr marL="0" indent="0">
+              <a:buNone/>
+            </a:pPr>
+            <a:r>
+              <a:rPr lang="en-GB" dirty="0"/>
+              <a:t>You may have come up with activities from the list below</a:t>
+            </a:r>
+          </a:p>
+          <a:p>
+            <a:pPr marL="0" indent="0">
+              <a:buNone/>
+            </a:pPr>
+            <a:endParaRPr lang="en-GB" dirty="0"/>
+          </a:p>
+          <a:p>
+            <a:r>
+              <a:rPr lang="en-GB" dirty="0"/>
+              <a:t>Travel to/from place of work</a:t>
+            </a:r>
+          </a:p>
+          <a:p>
+            <a:r>
+              <a:rPr lang="en-GB" dirty="0"/>
+              <a:t>Travel and accommodation for conferences, training and meetings</a:t>
+            </a:r>
+          </a:p>
+          <a:p>
+            <a:r>
+              <a:rPr lang="en-GB" dirty="0"/>
+              <a:t>Use of non-HPC computing resources</a:t>
+            </a:r>
+          </a:p>
+          <a:p>
+            <a:pPr lvl="1"/>
+            <a:r>
+              <a:rPr lang="en-GB" dirty="0"/>
+              <a:t>e.g. laptops/workstations, cloud resources and the internet</a:t>
+            </a:r>
+          </a:p>
+          <a:p>
+            <a:r>
+              <a:rPr lang="en-GB" dirty="0"/>
+              <a:t>Data storage</a:t>
+            </a:r>
+          </a:p>
+          <a:p>
+            <a:r>
+              <a:rPr lang="en-GB" dirty="0"/>
+              <a:t>Laboratory work, e.g. chemicals, instruments</a:t>
+            </a:r>
+          </a:p>
+          <a:p>
+            <a:r>
+              <a:rPr lang="en-GB" dirty="0"/>
+              <a:t>Printed materials, e.g. books, journal articles</a:t>
+            </a:r>
+          </a:p>
+          <a:p>
+            <a:pPr marL="0" indent="0">
+              <a:buNone/>
+            </a:pPr>
+            <a:endParaRPr lang="en-GB" dirty="0"/>
+          </a:p>
+          <a:p>
+            <a:pPr marL="0" indent="0">
+              <a:buNone/>
+            </a:pPr>
+            <a:r>
+              <a:rPr lang="en-GB" dirty="0"/>
+              <a:t>Ordering these by size of emission is more difficult and will differ from person to person.</a:t>
+            </a:r>
+          </a:p>
+          <a:p>
+            <a:pPr marL="0" indent="0">
+              <a:buNone/>
+            </a:pPr>
+            <a:r>
+              <a:rPr lang="en-GB" dirty="0"/>
+              <a:t>Typically, any sort of flying to conferences or meetings will be the most carbon intensive activity you can undertake through your work. Whether this is the largest contribution depends on how often you fly.</a:t>
+            </a:r>
+          </a:p>
+          <a:p>
+            <a:pPr marL="0" indent="0">
+              <a:buNone/>
+            </a:pPr>
+            <a:r>
+              <a:rPr lang="en-GB" dirty="0"/>
+              <a:t>If you work in a laboratory, that may well be the next highest source of emissions.</a:t>
+            </a:r>
+            <a:br>
+              <a:rPr lang="en-GB" dirty="0"/>
+            </a:br>
+            <a:r>
+              <a:rPr lang="en-GB" dirty="0"/>
+              <a:t>Use of a petrol/diesel may also place highly, especially if you have a long commute and travel alone.</a:t>
+            </a:r>
+          </a:p>
+        </p:txBody>
+      </p:sp>
+    </p:spTree>
+    <p:extLst>
+      <p:ext uri="{BB962C8B-B14F-4D97-AF65-F5344CB8AC3E}">
+        <p14:creationId xmlns:p14="http://schemas.microsoft.com/office/powerpoint/2010/main" val="2205958413"/>
+      </p:ext>
+    </p:extLst>
+  </p:cSld>
+  <p:clrMapOvr>
+    <a:masterClrMapping/>
+  </p:clrMapOvr>
+</p:sld>
+</file>
+
+<file path=ppt/slides/slide12.xml><?xml version="1.0" encoding="utf-8"?>
+<p:sld xmlns:a="http://schemas.openxmlformats.org/drawingml/2006/main" xmlns:r="http://schemas.openxmlformats.org/officeDocument/2006/relationships" xmlns:p="http://schemas.openxmlformats.org/presentationml/2006/main">
+  <p:cSld>
+    <p:spTree>
+      <p:nvGrpSpPr>
+        <p:cNvPr id="1" name=""/>
+        <p:cNvGrpSpPr/>
+        <p:nvPr/>
+      </p:nvGrpSpPr>
+      <p:grpSpPr>
+        <a:xfrm>
+          <a:off x="0" y="0"/>
+          <a:ext cx="0" cy="0"/>
+          <a:chOff x="0" y="0"/>
+          <a:chExt cx="0" cy="0"/>
+        </a:xfrm>
+      </p:grpSpPr>
+      <p:sp>
+        <p:nvSpPr>
+          <p:cNvPr id="2" name="Title 1">
+            <a:extLst>
+              <a:ext uri="{FF2B5EF4-FFF2-40B4-BE49-F238E27FC236}">
                 <a16:creationId xmlns:a16="http://schemas.microsoft.com/office/drawing/2014/main" id="{C653FCB3-0412-EB70-FD2D-95C9BA50D7F2}"/>
               </a:ext>
             </a:extLst>
@@ -4052,7 +4380,7 @@
 </p:sld>
 </file>
 
-<file path=ppt/slides/slide11.xml><?xml version="1.0" encoding="utf-8"?>
+<file path=ppt/slides/slide13.xml><?xml version="1.0" encoding="utf-8"?>
 <p:sld xmlns:a="http://schemas.openxmlformats.org/drawingml/2006/main" xmlns:r="http://schemas.openxmlformats.org/officeDocument/2006/relationships" xmlns:p="http://schemas.openxmlformats.org/presentationml/2006/main">
   <p:cSld>
     <p:spTree>
@@ -4744,188 +5072,155 @@
           <a:chExt cx="0" cy="0"/>
         </a:xfrm>
       </p:grpSpPr>
-      <p:sp>
-        <p:nvSpPr>
-          <p:cNvPr id="2" name="Title 1">
-            <a:extLst>
-              <a:ext uri="{FF2B5EF4-FFF2-40B4-BE49-F238E27FC236}">
-                <a16:creationId xmlns:a16="http://schemas.microsoft.com/office/drawing/2014/main" id="{44640606-FF4D-94A3-0FD8-965FD9218B24}"/>
-              </a:ext>
-            </a:extLst>
-          </p:cNvPr>
-          <p:cNvSpPr>
-            <a:spLocks noGrp="1"/>
-          </p:cNvSpPr>
-          <p:nvPr>
-            <p:ph type="title"/>
-          </p:nvPr>
-        </p:nvSpPr>
-        <p:spPr/>
-        <p:txBody>
-          <a:bodyPr/>
-          <a:lstStyle/>
-          <a:p>
-            <a:r>
-              <a:rPr lang="en-GB" dirty="0"/>
-              <a:t>Why does individual action matter?</a:t>
-            </a:r>
-          </a:p>
-        </p:txBody>
-      </p:sp>
-      <p:sp>
-        <p:nvSpPr>
-          <p:cNvPr id="3" name="Content Placeholder 2">
-            <a:extLst>
-              <a:ext uri="{FF2B5EF4-FFF2-40B4-BE49-F238E27FC236}">
-                <a16:creationId xmlns:a16="http://schemas.microsoft.com/office/drawing/2014/main" id="{B28162B9-9F2A-E76E-3563-0DEAB97820C1}"/>
-              </a:ext>
-            </a:extLst>
-          </p:cNvPr>
-          <p:cNvSpPr>
-            <a:spLocks noGrp="1"/>
-          </p:cNvSpPr>
-          <p:nvPr>
-            <p:ph idx="1"/>
-          </p:nvPr>
-        </p:nvSpPr>
+      <p:pic>
+        <p:nvPicPr>
+          <p:cNvPr id="7" name="Picture 6">
+            <a:extLst>
+              <a:ext uri="{FF2B5EF4-FFF2-40B4-BE49-F238E27FC236}">
+                <a16:creationId xmlns:a16="http://schemas.microsoft.com/office/drawing/2014/main" id="{D11612C0-2B2B-5631-4F2A-C1CF159B7383}"/>
+              </a:ext>
+            </a:extLst>
+          </p:cNvPr>
+          <p:cNvPicPr>
+            <a:picLocks noChangeAspect="1"/>
+          </p:cNvPicPr>
+          <p:nvPr/>
+        </p:nvPicPr>
+        <p:blipFill>
+          <a:blip r:embed="rId2"/>
+          <a:stretch>
+            <a:fillRect/>
+          </a:stretch>
+        </p:blipFill>
         <p:spPr>
           <a:xfrm>
-            <a:off x="609600" y="1385532"/>
-            <a:ext cx="10972800" cy="5067300"/>
+            <a:off x="838200" y="286092"/>
+            <a:ext cx="5671593" cy="5353983"/>
           </a:xfrm>
+          <a:prstGeom prst="rect">
+            <a:avLst/>
+          </a:prstGeom>
         </p:spPr>
-        <p:txBody>
-          <a:bodyPr>
-            <a:normAutofit fontScale="92500" lnSpcReduction="10000"/>
+      </p:pic>
+      <p:sp>
+        <p:nvSpPr>
+          <p:cNvPr id="8" name="TextBox 7">
+            <a:extLst>
+              <a:ext uri="{FF2B5EF4-FFF2-40B4-BE49-F238E27FC236}">
+                <a16:creationId xmlns:a16="http://schemas.microsoft.com/office/drawing/2014/main" id="{70551C7E-B199-2FC2-B64E-4D03835F7CE8}"/>
+              </a:ext>
+            </a:extLst>
+          </p:cNvPr>
+          <p:cNvSpPr txBox="1"/>
+          <p:nvPr/>
+        </p:nvSpPr>
+        <p:spPr>
+          <a:xfrm>
+            <a:off x="832945" y="5640075"/>
+            <a:ext cx="6574220" cy="738664"/>
+          </a:xfrm>
+          <a:prstGeom prst="rect">
+            <a:avLst/>
+          </a:prstGeom>
+          <a:noFill/>
+        </p:spPr>
+        <p:txBody>
+          <a:bodyPr wrap="square" rtlCol="0">
+            <a:spAutoFit/>
           </a:bodyPr>
           <a:lstStyle/>
           <a:p>
             <a:r>
-              <a:rPr lang="en-GB" dirty="0"/>
-              <a:t>Common comments:</a:t>
-            </a:r>
-          </a:p>
-          <a:p>
-            <a:pPr lvl="1"/>
-            <a:r>
-              <a:rPr lang="en-GB" i="1" dirty="0"/>
-              <a:t>“It is a global challenge, my individual action does not matter.”</a:t>
-            </a:r>
-          </a:p>
-          <a:p>
-            <a:pPr lvl="1"/>
-            <a:r>
-              <a:rPr lang="en-GB" i="1" dirty="0"/>
-              <a:t>“The UK emissions are small compared to China or the USA, why should we act first and create hardship for ourselves?”</a:t>
-            </a:r>
-          </a:p>
-          <a:p>
-            <a:pPr lvl="1"/>
-            <a:r>
-              <a:rPr lang="en-GB" i="1" dirty="0"/>
-              <a:t>“Discussing individual action helps large organisations absolve themselves of needing to act.”</a:t>
-            </a:r>
-          </a:p>
-          <a:p>
-            <a:r>
-              <a:rPr lang="en-GB" dirty="0"/>
-              <a:t>Taking no action is not a reasonable response – things we do as individuals have a real impact and we can be a meaningful force for change by:</a:t>
-            </a:r>
-          </a:p>
-          <a:p>
-            <a:pPr lvl="1"/>
-            <a:r>
-              <a:rPr lang="en-GB" dirty="0"/>
-              <a:t>Exerting pressure on workplaces, councils, governments, companies, etc. to make changes</a:t>
-            </a:r>
-          </a:p>
-          <a:p>
-            <a:pPr lvl="1"/>
-            <a:r>
-              <a:rPr lang="en-GB" dirty="0"/>
-              <a:t>Leading by example</a:t>
-            </a:r>
-          </a:p>
-          <a:p>
-            <a:pPr lvl="1"/>
-            <a:r>
-              <a:rPr lang="en-GB" dirty="0"/>
-              <a:t>Normalising discussion and activism</a:t>
-            </a:r>
-          </a:p>
-          <a:p>
-            <a:r>
-              <a:rPr lang="en-GB" dirty="0"/>
-              <a:t>We must ensure that discussions and action by ourselves is always placed in the context of holding large organisations to account</a:t>
-            </a:r>
-          </a:p>
-          <a:p>
-            <a:pPr lvl="1"/>
-            <a:endParaRPr lang="en-GB" dirty="0"/>
-          </a:p>
-        </p:txBody>
-      </p:sp>
-      <p:sp>
-        <p:nvSpPr>
-          <p:cNvPr id="4" name="Footer Placeholder 3">
-            <a:extLst>
-              <a:ext uri="{FF2B5EF4-FFF2-40B4-BE49-F238E27FC236}">
-                <a16:creationId xmlns:a16="http://schemas.microsoft.com/office/drawing/2014/main" id="{33532C58-52B8-2637-CD46-0EFB4FD19222}"/>
-              </a:ext>
-            </a:extLst>
-          </p:cNvPr>
-          <p:cNvSpPr>
-            <a:spLocks noGrp="1"/>
-          </p:cNvSpPr>
-          <p:nvPr>
-            <p:ph type="ftr" sz="quarter" idx="11"/>
-          </p:nvPr>
-        </p:nvSpPr>
-        <p:spPr/>
-        <p:txBody>
-          <a:bodyPr/>
-          <a:lstStyle/>
-          <a:p>
-            <a:r>
-              <a:rPr lang="en-US"/>
-              <a:t>EPCC, The University of Edinburgh</a:t>
-            </a:r>
-          </a:p>
-        </p:txBody>
-      </p:sp>
-      <p:sp>
-        <p:nvSpPr>
-          <p:cNvPr id="5" name="Slide Number Placeholder 4">
-            <a:extLst>
-              <a:ext uri="{FF2B5EF4-FFF2-40B4-BE49-F238E27FC236}">
-                <a16:creationId xmlns:a16="http://schemas.microsoft.com/office/drawing/2014/main" id="{2640A148-A2E7-2AE2-66F6-68F4282BB406}"/>
-              </a:ext>
-            </a:extLst>
-          </p:cNvPr>
-          <p:cNvSpPr>
-            <a:spLocks noGrp="1"/>
-          </p:cNvSpPr>
-          <p:nvPr>
-            <p:ph type="sldNum" sz="quarter" idx="12"/>
-          </p:nvPr>
-        </p:nvSpPr>
-        <p:spPr/>
-        <p:txBody>
-          <a:bodyPr/>
-          <a:lstStyle/>
-          <a:p>
-            <a:fld id="{2E673B58-0F97-924D-B08E-6218A6BAD949}" type="slidenum">
-              <a:rPr lang="en-US" smtClean="0"/>
-              <a:t>4</a:t>
-            </a:fld>
-            <a:endParaRPr lang="en-US"/>
+              <a:rPr lang="en-GB" sz="1400" dirty="0">
+                <a:latin typeface="Helvetica" pitchFamily="2" charset="0"/>
+              </a:rPr>
+              <a:t>Credit: "Azote for Stockholm Resilience Centre, based on analysis in Sakschewski and Caesar et al. 2025".</a:t>
+            </a:r>
+          </a:p>
+          <a:p>
+            <a:r>
+              <a:rPr lang="en-GB" sz="1400" dirty="0">
+                <a:latin typeface="Helvetica" pitchFamily="2" charset="0"/>
+                <a:hlinkClick r:id="rId3"/>
+              </a:rPr>
+              <a:t>https://www.stockholmresilience.org/research/planetary-boundaries.html</a:t>
+            </a:r>
+            <a:r>
+              <a:rPr lang="en-GB" sz="1400" dirty="0">
+                <a:latin typeface="Helvetica" pitchFamily="2" charset="0"/>
+              </a:rPr>
+              <a:t> </a:t>
+            </a:r>
+          </a:p>
+        </p:txBody>
+      </p:sp>
+      <p:sp>
+        <p:nvSpPr>
+          <p:cNvPr id="9" name="TextBox 8">
+            <a:extLst>
+              <a:ext uri="{FF2B5EF4-FFF2-40B4-BE49-F238E27FC236}">
+                <a16:creationId xmlns:a16="http://schemas.microsoft.com/office/drawing/2014/main" id="{2E106FF9-9F43-00D0-9B78-AE59809D5D2D}"/>
+              </a:ext>
+            </a:extLst>
+          </p:cNvPr>
+          <p:cNvSpPr txBox="1"/>
+          <p:nvPr/>
+        </p:nvSpPr>
+        <p:spPr>
+          <a:xfrm>
+            <a:off x="7512733" y="1679955"/>
+            <a:ext cx="4307232" cy="3970318"/>
+          </a:xfrm>
+          <a:prstGeom prst="rect">
+            <a:avLst/>
+          </a:prstGeom>
+          <a:noFill/>
+        </p:spPr>
+        <p:txBody>
+          <a:bodyPr wrap="square" rtlCol="0">
+            <a:spAutoFit/>
+          </a:bodyPr>
+          <a:lstStyle/>
+          <a:p>
+            <a:r>
+              <a:rPr lang="en-GB" dirty="0">
+                <a:latin typeface="Helvetica" pitchFamily="2" charset="0"/>
+              </a:rPr>
+              <a:t>The issues are wider than just GHG emissions</a:t>
+            </a:r>
+          </a:p>
+          <a:p>
+            <a:endParaRPr lang="en-GB" dirty="0">
+              <a:latin typeface="Helvetica" pitchFamily="2" charset="0"/>
+            </a:endParaRPr>
+          </a:p>
+          <a:p>
+            <a:r>
+              <a:rPr lang="en-GB" dirty="0">
+                <a:latin typeface="Helvetica" pitchFamily="2" charset="0"/>
+              </a:rPr>
+              <a:t>Multiple measures of earth systems integrity are being breached</a:t>
+            </a:r>
+          </a:p>
+          <a:p>
+            <a:endParaRPr lang="en-GB" dirty="0">
+              <a:latin typeface="Helvetica" pitchFamily="2" charset="0"/>
+            </a:endParaRPr>
+          </a:p>
+          <a:p>
+            <a:r>
+              <a:rPr lang="en-GB" i="1" dirty="0">
+                <a:latin typeface="Helvetica" pitchFamily="2" charset="0"/>
+              </a:rPr>
+              <a:t>“Planetary boundaries are interdependent. This means we cannot consider planetary boundaries in isolation in any decision-making on sustainability. Action that affects one process in the planetary boundaries framework will affect the risks of the other processes.”</a:t>
+            </a:r>
           </a:p>
         </p:txBody>
       </p:sp>
     </p:spTree>
     <p:extLst>
       <p:ext uri="{BB962C8B-B14F-4D97-AF65-F5344CB8AC3E}">
-        <p14:creationId xmlns:p14="http://schemas.microsoft.com/office/powerpoint/2010/main" val="1332744819"/>
+        <p14:creationId xmlns:p14="http://schemas.microsoft.com/office/powerpoint/2010/main" val="4071893396"/>
       </p:ext>
     </p:extLst>
   </p:cSld>
@@ -4954,10 +5249,314 @@
       </p:grpSpPr>
       <p:sp>
         <p:nvSpPr>
+          <p:cNvPr id="2" name="Title 1">
+            <a:extLst>
+              <a:ext uri="{FF2B5EF4-FFF2-40B4-BE49-F238E27FC236}">
+                <a16:creationId xmlns:a16="http://schemas.microsoft.com/office/drawing/2014/main" id="{F36CE2D3-4B18-788E-DE2C-1A79D1444056}"/>
+              </a:ext>
+            </a:extLst>
+          </p:cNvPr>
+          <p:cNvSpPr>
+            <a:spLocks noGrp="1"/>
+          </p:cNvSpPr>
+          <p:nvPr>
+            <p:ph type="title"/>
+          </p:nvPr>
+        </p:nvSpPr>
+        <p:spPr>
+          <a:xfrm>
+            <a:off x="838200" y="92411"/>
+            <a:ext cx="10515600" cy="1325563"/>
+          </a:xfrm>
+        </p:spPr>
+        <p:txBody>
+          <a:bodyPr/>
+          <a:lstStyle/>
+          <a:p>
+            <a:r>
+              <a:rPr lang="en-GB" dirty="0"/>
+              <a:t>Positive signs</a:t>
+            </a:r>
+          </a:p>
+        </p:txBody>
+      </p:sp>
+      <p:pic>
+        <p:nvPicPr>
+          <p:cNvPr id="4" name="Picture 3">
+            <a:extLst>
+              <a:ext uri="{FF2B5EF4-FFF2-40B4-BE49-F238E27FC236}">
+                <a16:creationId xmlns:a16="http://schemas.microsoft.com/office/drawing/2014/main" id="{AD19C9C2-4156-B619-CC59-A26D60D2F64E}"/>
+              </a:ext>
+            </a:extLst>
+          </p:cNvPr>
+          <p:cNvPicPr>
+            <a:picLocks noChangeAspect="1"/>
+          </p:cNvPicPr>
+          <p:nvPr/>
+        </p:nvPicPr>
+        <p:blipFill>
+          <a:blip r:embed="rId3"/>
+          <a:stretch>
+            <a:fillRect/>
+          </a:stretch>
+        </p:blipFill>
+        <p:spPr>
+          <a:xfrm>
+            <a:off x="1656348" y="1292601"/>
+            <a:ext cx="2729580" cy="2729580"/>
+          </a:xfrm>
+          <a:prstGeom prst="rect">
+            <a:avLst/>
+          </a:prstGeom>
+        </p:spPr>
+      </p:pic>
+      <p:pic>
+        <p:nvPicPr>
+          <p:cNvPr id="5" name="Picture 4">
+            <a:extLst>
+              <a:ext uri="{FF2B5EF4-FFF2-40B4-BE49-F238E27FC236}">
+                <a16:creationId xmlns:a16="http://schemas.microsoft.com/office/drawing/2014/main" id="{2E872DBF-DA76-9CFA-0502-265021FE2045}"/>
+              </a:ext>
+            </a:extLst>
+          </p:cNvPr>
+          <p:cNvPicPr>
+            <a:picLocks noChangeAspect="1"/>
+          </p:cNvPicPr>
+          <p:nvPr/>
+        </p:nvPicPr>
+        <p:blipFill>
+          <a:blip r:embed="rId4"/>
+          <a:stretch>
+            <a:fillRect/>
+          </a:stretch>
+        </p:blipFill>
+        <p:spPr>
+          <a:xfrm>
+            <a:off x="5907507" y="3836275"/>
+            <a:ext cx="5216576" cy="2915486"/>
+          </a:xfrm>
+          <a:prstGeom prst="rect">
+            <a:avLst/>
+          </a:prstGeom>
+        </p:spPr>
+      </p:pic>
+      <p:pic>
+        <p:nvPicPr>
+          <p:cNvPr id="7" name="Picture 6">
+            <a:extLst>
+              <a:ext uri="{FF2B5EF4-FFF2-40B4-BE49-F238E27FC236}">
+                <a16:creationId xmlns:a16="http://schemas.microsoft.com/office/drawing/2014/main" id="{60B95385-FFBA-CFFA-670B-51F195DAAD3D}"/>
+              </a:ext>
+            </a:extLst>
+          </p:cNvPr>
+          <p:cNvPicPr>
+            <a:picLocks noChangeAspect="1"/>
+          </p:cNvPicPr>
+          <p:nvPr/>
+        </p:nvPicPr>
+        <p:blipFill>
+          <a:blip r:embed="rId5"/>
+          <a:stretch>
+            <a:fillRect/>
+          </a:stretch>
+        </p:blipFill>
+        <p:spPr>
+          <a:xfrm>
+            <a:off x="5247867" y="365125"/>
+            <a:ext cx="4522537" cy="3192379"/>
+          </a:xfrm>
+          <a:prstGeom prst="rect">
+            <a:avLst/>
+          </a:prstGeom>
+        </p:spPr>
+      </p:pic>
+      <p:pic>
+        <p:nvPicPr>
+          <p:cNvPr id="8" name="Picture 7">
+            <a:extLst>
+              <a:ext uri="{FF2B5EF4-FFF2-40B4-BE49-F238E27FC236}">
+                <a16:creationId xmlns:a16="http://schemas.microsoft.com/office/drawing/2014/main" id="{A723EB65-7859-E187-91B1-E444E79C2487}"/>
+              </a:ext>
+            </a:extLst>
+          </p:cNvPr>
+          <p:cNvPicPr>
+            <a:picLocks noChangeAspect="1"/>
+          </p:cNvPicPr>
+          <p:nvPr/>
+        </p:nvPicPr>
+        <p:blipFill>
+          <a:blip r:embed="rId6"/>
+          <a:stretch>
+            <a:fillRect/>
+          </a:stretch>
+        </p:blipFill>
+        <p:spPr>
+          <a:xfrm>
+            <a:off x="1267581" y="4022181"/>
+            <a:ext cx="4236960" cy="2729580"/>
+          </a:xfrm>
+          <a:prstGeom prst="rect">
+            <a:avLst/>
+          </a:prstGeom>
+        </p:spPr>
+      </p:pic>
+    </p:spTree>
+    <p:extLst>
+      <p:ext uri="{BB962C8B-B14F-4D97-AF65-F5344CB8AC3E}">
+        <p14:creationId xmlns:p14="http://schemas.microsoft.com/office/powerpoint/2010/main" val="1493838822"/>
+      </p:ext>
+    </p:extLst>
+  </p:cSld>
+  <p:clrMapOvr>
+    <a:masterClrMapping/>
+  </p:clrMapOvr>
+</p:sld>
+</file>
+
+<file path=ppt/slides/slide6.xml><?xml version="1.0" encoding="utf-8"?>
+<p:sld xmlns:a="http://schemas.openxmlformats.org/drawingml/2006/main" xmlns:r="http://schemas.openxmlformats.org/officeDocument/2006/relationships" xmlns:p="http://schemas.openxmlformats.org/presentationml/2006/main">
+  <p:cSld>
+    <p:spTree>
+      <p:nvGrpSpPr>
+        <p:cNvPr id="1" name=""/>
+        <p:cNvGrpSpPr/>
+        <p:nvPr/>
+      </p:nvGrpSpPr>
+      <p:grpSpPr>
+        <a:xfrm>
+          <a:off x="0" y="0"/>
+          <a:ext cx="0" cy="0"/>
+          <a:chOff x="0" y="0"/>
+          <a:chExt cx="0" cy="0"/>
+        </a:xfrm>
+      </p:grpSpPr>
+      <p:sp>
+        <p:nvSpPr>
+          <p:cNvPr id="2" name="Title 1">
+            <a:extLst>
+              <a:ext uri="{FF2B5EF4-FFF2-40B4-BE49-F238E27FC236}">
+                <a16:creationId xmlns:a16="http://schemas.microsoft.com/office/drawing/2014/main" id="{44640606-FF4D-94A3-0FD8-965FD9218B24}"/>
+              </a:ext>
+            </a:extLst>
+          </p:cNvPr>
+          <p:cNvSpPr>
+            <a:spLocks noGrp="1"/>
+          </p:cNvSpPr>
+          <p:nvPr>
+            <p:ph type="title"/>
+          </p:nvPr>
+        </p:nvSpPr>
+        <p:spPr/>
+        <p:txBody>
+          <a:bodyPr/>
+          <a:lstStyle/>
+          <a:p>
+            <a:r>
+              <a:rPr lang="en-GB" dirty="0"/>
+              <a:t>Why does individual action matter?</a:t>
+            </a:r>
+          </a:p>
+        </p:txBody>
+      </p:sp>
+      <p:sp>
+        <p:nvSpPr>
+          <p:cNvPr id="3" name="Content Placeholder 2">
+            <a:extLst>
+              <a:ext uri="{FF2B5EF4-FFF2-40B4-BE49-F238E27FC236}">
+                <a16:creationId xmlns:a16="http://schemas.microsoft.com/office/drawing/2014/main" id="{B28162B9-9F2A-E76E-3563-0DEAB97820C1}"/>
+              </a:ext>
+            </a:extLst>
+          </p:cNvPr>
+          <p:cNvSpPr>
+            <a:spLocks noGrp="1"/>
+          </p:cNvSpPr>
+          <p:nvPr>
+            <p:ph idx="1"/>
+          </p:nvPr>
+        </p:nvSpPr>
+        <p:spPr>
+          <a:xfrm>
+            <a:off x="609600" y="1385532"/>
+            <a:ext cx="10972800" cy="5067300"/>
+          </a:xfrm>
+        </p:spPr>
+        <p:txBody>
+          <a:bodyPr>
+            <a:normAutofit fontScale="92500" lnSpcReduction="10000"/>
+          </a:bodyPr>
+          <a:lstStyle/>
+          <a:p>
+            <a:r>
+              <a:rPr lang="en-GB" dirty="0"/>
+              <a:t>Common comments:</a:t>
+            </a:r>
+          </a:p>
+          <a:p>
+            <a:pPr lvl="1"/>
+            <a:r>
+              <a:rPr lang="en-GB" i="1" dirty="0"/>
+              <a:t>“It is a global challenge, my individual action does not matter.”</a:t>
+            </a:r>
+          </a:p>
+          <a:p>
+            <a:pPr lvl="1"/>
+            <a:r>
+              <a:rPr lang="en-GB" i="1" dirty="0"/>
+              <a:t>“The UK emissions are small compared to China or the USA, why should we act first and create hardship for ourselves?”</a:t>
+            </a:r>
+          </a:p>
+          <a:p>
+            <a:pPr lvl="1"/>
+            <a:r>
+              <a:rPr lang="en-GB" i="1" dirty="0"/>
+              <a:t>“Discussing individual action helps large organisations absolve themselves of needing to act.”</a:t>
+            </a:r>
+          </a:p>
+          <a:p>
+            <a:r>
+              <a:rPr lang="en-GB" dirty="0"/>
+              <a:t>Taking no action is not a reasonable response – things we do as individuals have a real impact and we can be a meaningful force for change by:</a:t>
+            </a:r>
+          </a:p>
+          <a:p>
+            <a:pPr lvl="1"/>
+            <a:r>
+              <a:rPr lang="en-GB" dirty="0"/>
+              <a:t>Exerting pressure on workplaces, councils, governments, companies, etc. to make changes</a:t>
+            </a:r>
+          </a:p>
+          <a:p>
+            <a:pPr lvl="1"/>
+            <a:r>
+              <a:rPr lang="en-GB" dirty="0"/>
+              <a:t>Leading by example</a:t>
+            </a:r>
+          </a:p>
+          <a:p>
+            <a:pPr lvl="1"/>
+            <a:r>
+              <a:rPr lang="en-GB" dirty="0"/>
+              <a:t>Normalising discussion and activism</a:t>
+            </a:r>
+          </a:p>
+          <a:p>
+            <a:r>
+              <a:rPr lang="en-GB" dirty="0"/>
+              <a:t>We must ensure that discussions and action by ourselves is always placed in the context of holding large organisations to account</a:t>
+            </a:r>
+          </a:p>
+          <a:p>
+            <a:pPr lvl="1"/>
+            <a:endParaRPr lang="en-GB" dirty="0"/>
+          </a:p>
+        </p:txBody>
+      </p:sp>
+      <p:sp>
+        <p:nvSpPr>
           <p:cNvPr id="4" name="Footer Placeholder 3">
             <a:extLst>
               <a:ext uri="{FF2B5EF4-FFF2-40B4-BE49-F238E27FC236}">
-                <a16:creationId xmlns:a16="http://schemas.microsoft.com/office/drawing/2014/main" id="{2A8B5E8B-1DA1-1B89-8A22-4A3FE0E3CE2D}"/>
+                <a16:creationId xmlns:a16="http://schemas.microsoft.com/office/drawing/2014/main" id="{33532C58-52B8-2637-CD46-0EFB4FD19222}"/>
               </a:ext>
             </a:extLst>
           </p:cNvPr>
@@ -4985,7 +5584,7 @@
           <p:cNvPr id="5" name="Slide Number Placeholder 4">
             <a:extLst>
               <a:ext uri="{FF2B5EF4-FFF2-40B4-BE49-F238E27FC236}">
-                <a16:creationId xmlns:a16="http://schemas.microsoft.com/office/drawing/2014/main" id="{8A0962C4-0CF9-B288-88F6-9F95B01F4C9D}"/>
+                <a16:creationId xmlns:a16="http://schemas.microsoft.com/office/drawing/2014/main" id="{2640A148-A2E7-2AE2-66F6-68F4282BB406}"/>
               </a:ext>
             </a:extLst>
           </p:cNvPr>
@@ -5003,7 +5602,94 @@
           <a:p>
             <a:fld id="{2E673B58-0F97-924D-B08E-6218A6BAD949}" type="slidenum">
               <a:rPr lang="en-US" smtClean="0"/>
-              <a:t>5</a:t>
+              <a:t>6</a:t>
+            </a:fld>
+            <a:endParaRPr lang="en-US"/>
+          </a:p>
+        </p:txBody>
+      </p:sp>
+    </p:spTree>
+    <p:extLst>
+      <p:ext uri="{BB962C8B-B14F-4D97-AF65-F5344CB8AC3E}">
+        <p14:creationId xmlns:p14="http://schemas.microsoft.com/office/powerpoint/2010/main" val="1332744819"/>
+      </p:ext>
+    </p:extLst>
+  </p:cSld>
+  <p:clrMapOvr>
+    <a:masterClrMapping/>
+  </p:clrMapOvr>
+</p:sld>
+</file>
+
+<file path=ppt/slides/slide7.xml><?xml version="1.0" encoding="utf-8"?>
+<p:sld xmlns:a="http://schemas.openxmlformats.org/drawingml/2006/main" xmlns:r="http://schemas.openxmlformats.org/officeDocument/2006/relationships" xmlns:p="http://schemas.openxmlformats.org/presentationml/2006/main">
+  <p:cSld>
+    <p:spTree>
+      <p:nvGrpSpPr>
+        <p:cNvPr id="1" name=""/>
+        <p:cNvGrpSpPr/>
+        <p:nvPr/>
+      </p:nvGrpSpPr>
+      <p:grpSpPr>
+        <a:xfrm>
+          <a:off x="0" y="0"/>
+          <a:ext cx="0" cy="0"/>
+          <a:chOff x="0" y="0"/>
+          <a:chExt cx="0" cy="0"/>
+        </a:xfrm>
+      </p:grpSpPr>
+      <p:sp>
+        <p:nvSpPr>
+          <p:cNvPr id="4" name="Footer Placeholder 3">
+            <a:extLst>
+              <a:ext uri="{FF2B5EF4-FFF2-40B4-BE49-F238E27FC236}">
+                <a16:creationId xmlns:a16="http://schemas.microsoft.com/office/drawing/2014/main" id="{2A8B5E8B-1DA1-1B89-8A22-4A3FE0E3CE2D}"/>
+              </a:ext>
+            </a:extLst>
+          </p:cNvPr>
+          <p:cNvSpPr>
+            <a:spLocks noGrp="1"/>
+          </p:cNvSpPr>
+          <p:nvPr>
+            <p:ph type="ftr" sz="quarter" idx="11"/>
+          </p:nvPr>
+        </p:nvSpPr>
+        <p:spPr/>
+        <p:txBody>
+          <a:bodyPr/>
+          <a:lstStyle/>
+          <a:p>
+            <a:r>
+              <a:rPr lang="en-US"/>
+              <a:t>EPCC, The University of Edinburgh</a:t>
+            </a:r>
+          </a:p>
+        </p:txBody>
+      </p:sp>
+      <p:sp>
+        <p:nvSpPr>
+          <p:cNvPr id="5" name="Slide Number Placeholder 4">
+            <a:extLst>
+              <a:ext uri="{FF2B5EF4-FFF2-40B4-BE49-F238E27FC236}">
+                <a16:creationId xmlns:a16="http://schemas.microsoft.com/office/drawing/2014/main" id="{8A0962C4-0CF9-B288-88F6-9F95B01F4C9D}"/>
+              </a:ext>
+            </a:extLst>
+          </p:cNvPr>
+          <p:cNvSpPr>
+            <a:spLocks noGrp="1"/>
+          </p:cNvSpPr>
+          <p:nvPr>
+            <p:ph type="sldNum" sz="quarter" idx="12"/>
+          </p:nvPr>
+        </p:nvSpPr>
+        <p:spPr/>
+        <p:txBody>
+          <a:bodyPr/>
+          <a:lstStyle/>
+          <a:p>
+            <a:fld id="{2E673B58-0F97-924D-B08E-6218A6BAD949}" type="slidenum">
+              <a:rPr lang="en-US" smtClean="0"/>
+              <a:t>7</a:t>
             </a:fld>
             <a:endParaRPr lang="en-US"/>
           </a:p>
@@ -5656,7 +6342,7 @@
 </p:sld>
 </file>
 
-<file path=ppt/slides/slide6.xml><?xml version="1.0" encoding="utf-8"?>
+<file path=ppt/slides/slide8.xml><?xml version="1.0" encoding="utf-8"?>
 <p:sld xmlns:a="http://schemas.openxmlformats.org/drawingml/2006/main" xmlns:r="http://schemas.openxmlformats.org/officeDocument/2006/relationships" xmlns:p="http://schemas.openxmlformats.org/presentationml/2006/main">
   <p:cSld>
     <p:spTree>
@@ -6215,321 +6901,6 @@
 </p:sld>
 </file>
 
-<file path=ppt/slides/slide7.xml><?xml version="1.0" encoding="utf-8"?>
-<p:sld xmlns:a="http://schemas.openxmlformats.org/drawingml/2006/main" xmlns:r="http://schemas.openxmlformats.org/officeDocument/2006/relationships" xmlns:p="http://schemas.openxmlformats.org/presentationml/2006/main">
-  <p:cSld>
-    <p:spTree>
-      <p:nvGrpSpPr>
-        <p:cNvPr id="1" name=""/>
-        <p:cNvGrpSpPr/>
-        <p:nvPr/>
-      </p:nvGrpSpPr>
-      <p:grpSpPr>
-        <a:xfrm>
-          <a:off x="0" y="0"/>
-          <a:ext cx="0" cy="0"/>
-          <a:chOff x="0" y="0"/>
-          <a:chExt cx="0" cy="0"/>
-        </a:xfrm>
-      </p:grpSpPr>
-      <p:sp>
-        <p:nvSpPr>
-          <p:cNvPr id="2" name="Title 1">
-            <a:extLst>
-              <a:ext uri="{FF2B5EF4-FFF2-40B4-BE49-F238E27FC236}">
-                <a16:creationId xmlns:a16="http://schemas.microsoft.com/office/drawing/2014/main" id="{BC120409-6EB5-E11A-0230-8D3F0B1134E9}"/>
-              </a:ext>
-            </a:extLst>
-          </p:cNvPr>
-          <p:cNvSpPr>
-            <a:spLocks noGrp="1"/>
-          </p:cNvSpPr>
-          <p:nvPr>
-            <p:ph type="title"/>
-          </p:nvPr>
-        </p:nvSpPr>
-        <p:spPr/>
-        <p:txBody>
-          <a:bodyPr/>
-          <a:lstStyle/>
-          <a:p>
-            <a:r>
-              <a:rPr lang="en-GB" dirty="0"/>
-              <a:t>Course overview</a:t>
-            </a:r>
-          </a:p>
-        </p:txBody>
-      </p:sp>
-      <p:sp>
-        <p:nvSpPr>
-          <p:cNvPr id="3" name="Content Placeholder 2">
-            <a:extLst>
-              <a:ext uri="{FF2B5EF4-FFF2-40B4-BE49-F238E27FC236}">
-                <a16:creationId xmlns:a16="http://schemas.microsoft.com/office/drawing/2014/main" id="{FE3C14D3-ECF9-CFCD-8788-F6332655D99D}"/>
-              </a:ext>
-            </a:extLst>
-          </p:cNvPr>
-          <p:cNvSpPr>
-            <a:spLocks noGrp="1"/>
-          </p:cNvSpPr>
-          <p:nvPr>
-            <p:ph idx="1"/>
-          </p:nvPr>
-        </p:nvSpPr>
-        <p:spPr>
-          <a:xfrm>
-            <a:off x="838200" y="1509486"/>
-            <a:ext cx="10515600" cy="4983389"/>
-          </a:xfrm>
-        </p:spPr>
-        <p:txBody>
-          <a:bodyPr>
-            <a:normAutofit fontScale="77500" lnSpcReduction="20000"/>
-          </a:bodyPr>
-          <a:lstStyle/>
-          <a:p>
-            <a:pPr marL="0" indent="0">
-              <a:buNone/>
-            </a:pPr>
-            <a:r>
-              <a:rPr lang="en-GB" dirty="0"/>
-              <a:t>During this course, we will cover six key areas of green HPC, derived from the principles of green software engineering.</a:t>
-            </a:r>
-            <a:br>
-              <a:rPr lang="en-GB" dirty="0"/>
-            </a:br>
-            <a:endParaRPr lang="en-GB" dirty="0"/>
-          </a:p>
-          <a:p>
-            <a:r>
-              <a:rPr lang="en-GB" b="1" dirty="0"/>
-              <a:t>Carbon Efficiency</a:t>
-            </a:r>
-            <a:r>
-              <a:rPr lang="en-GB" dirty="0"/>
-              <a:t>: Emit the least amount of carbon possible.</a:t>
-            </a:r>
-          </a:p>
-          <a:p>
-            <a:r>
-              <a:rPr lang="en-GB" b="1" dirty="0"/>
-              <a:t>Energy Efficiency</a:t>
-            </a:r>
-            <a:r>
-              <a:rPr lang="en-GB" dirty="0"/>
-              <a:t>: Use the least amount of energy possible.</a:t>
-            </a:r>
-          </a:p>
-          <a:p>
-            <a:r>
-              <a:rPr lang="en-GB" b="1" dirty="0"/>
-              <a:t>Carbon Awareness</a:t>
-            </a:r>
-            <a:r>
-              <a:rPr lang="en-GB" dirty="0"/>
-              <a:t>: Do more when the electricity is "cleaner" and do less when the electricity is "dirtier".</a:t>
-            </a:r>
-          </a:p>
-          <a:p>
-            <a:r>
-              <a:rPr lang="en-GB" b="1" dirty="0"/>
-              <a:t>Hardware Efficiency</a:t>
-            </a:r>
-            <a:r>
-              <a:rPr lang="en-GB" dirty="0"/>
-              <a:t>: Use the least amount of embodied carbon possible.</a:t>
-            </a:r>
-          </a:p>
-          <a:p>
-            <a:r>
-              <a:rPr lang="en-GB" b="1" dirty="0"/>
-              <a:t>Measurement</a:t>
-            </a:r>
-            <a:r>
-              <a:rPr lang="en-GB" dirty="0"/>
-              <a:t>: What you cannot measure, you cannot improve.</a:t>
-            </a:r>
-          </a:p>
-          <a:p>
-            <a:r>
-              <a:rPr lang="en-GB" b="1" dirty="0"/>
-              <a:t>Reducing Emissions</a:t>
-            </a:r>
-            <a:r>
-              <a:rPr lang="en-GB" dirty="0"/>
-              <a:t>: Understand mechanisms of carbon reduction.</a:t>
-            </a:r>
-            <a:br>
-              <a:rPr lang="en-GB" dirty="0"/>
-            </a:br>
-            <a:endParaRPr lang="en-GB" dirty="0"/>
-          </a:p>
-          <a:p>
-            <a:pPr marL="0" indent="0">
-              <a:buNone/>
-            </a:pPr>
-            <a:r>
-              <a:rPr lang="en-GB" dirty="0"/>
-              <a:t>For each area, we'll introduce some new concepts and explain in detail why it is important in terms of the climate, and how you can apply them on HPC systems.</a:t>
-            </a:r>
-          </a:p>
-          <a:p>
-            <a:pPr marL="0" indent="0">
-              <a:buNone/>
-            </a:pPr>
-            <a:r>
-              <a:rPr lang="en-GB" dirty="0"/>
-              <a:t>We will use the </a:t>
-            </a:r>
-            <a:r>
-              <a:rPr lang="en-GB" dirty="0">
-                <a:hlinkClick r:id="rId2"/>
-              </a:rPr>
-              <a:t>ARCHER2 UK National Supercomputing Service</a:t>
-            </a:r>
-            <a:r>
-              <a:rPr lang="en-GB" dirty="0"/>
-              <a:t> to provide concrete examples of how the principles can be applied.</a:t>
-            </a:r>
-          </a:p>
-          <a:p>
-            <a:pPr marL="0" indent="0">
-              <a:buNone/>
-            </a:pPr>
-            <a:endParaRPr lang="en-GB" dirty="0"/>
-          </a:p>
-        </p:txBody>
-      </p:sp>
-    </p:spTree>
-    <p:extLst>
-      <p:ext uri="{BB962C8B-B14F-4D97-AF65-F5344CB8AC3E}">
-        <p14:creationId xmlns:p14="http://schemas.microsoft.com/office/powerpoint/2010/main" val="2548529128"/>
-      </p:ext>
-    </p:extLst>
-  </p:cSld>
-  <p:clrMapOvr>
-    <a:masterClrMapping/>
-  </p:clrMapOvr>
-</p:sld>
-</file>
-
-<file path=ppt/slides/slide8.xml><?xml version="1.0" encoding="utf-8"?>
-<p:sld xmlns:a="http://schemas.openxmlformats.org/drawingml/2006/main" xmlns:r="http://schemas.openxmlformats.org/officeDocument/2006/relationships" xmlns:p="http://schemas.openxmlformats.org/presentationml/2006/main">
-  <p:cSld>
-    <p:spTree>
-      <p:nvGrpSpPr>
-        <p:cNvPr id="1" name=""/>
-        <p:cNvGrpSpPr/>
-        <p:nvPr/>
-      </p:nvGrpSpPr>
-      <p:grpSpPr>
-        <a:xfrm>
-          <a:off x="0" y="0"/>
-          <a:ext cx="0" cy="0"/>
-          <a:chOff x="0" y="0"/>
-          <a:chExt cx="0" cy="0"/>
-        </a:xfrm>
-      </p:grpSpPr>
-      <p:sp>
-        <p:nvSpPr>
-          <p:cNvPr id="2" name="Title 1">
-            <a:extLst>
-              <a:ext uri="{FF2B5EF4-FFF2-40B4-BE49-F238E27FC236}">
-                <a16:creationId xmlns:a16="http://schemas.microsoft.com/office/drawing/2014/main" id="{534421AB-2E7C-0C8C-8B80-12FBE0BFF8D1}"/>
-              </a:ext>
-            </a:extLst>
-          </p:cNvPr>
-          <p:cNvSpPr>
-            <a:spLocks noGrp="1"/>
-          </p:cNvSpPr>
-          <p:nvPr>
-            <p:ph type="title"/>
-          </p:nvPr>
-        </p:nvSpPr>
-        <p:spPr/>
-        <p:txBody>
-          <a:bodyPr/>
-          <a:lstStyle/>
-          <a:p>
-            <a:r>
-              <a:rPr lang="en-GB" dirty="0">
-                <a:solidFill>
-                  <a:schemeClr val="accent3"/>
-                </a:solidFill>
-              </a:rPr>
-              <a:t>Exercise: Emissions from your work</a:t>
-            </a:r>
-          </a:p>
-        </p:txBody>
-      </p:sp>
-      <p:sp>
-        <p:nvSpPr>
-          <p:cNvPr id="3" name="Content Placeholder 2">
-            <a:extLst>
-              <a:ext uri="{FF2B5EF4-FFF2-40B4-BE49-F238E27FC236}">
-                <a16:creationId xmlns:a16="http://schemas.microsoft.com/office/drawing/2014/main" id="{4D3BEC50-78D0-1BFE-3014-63A622CBED21}"/>
-              </a:ext>
-            </a:extLst>
-          </p:cNvPr>
-          <p:cNvSpPr>
-            <a:spLocks noGrp="1"/>
-          </p:cNvSpPr>
-          <p:nvPr>
-            <p:ph idx="1"/>
-          </p:nvPr>
-        </p:nvSpPr>
-        <p:spPr/>
-        <p:txBody>
-          <a:bodyPr/>
-          <a:lstStyle/>
-          <a:p>
-            <a:pPr marL="0" indent="0">
-              <a:buNone/>
-            </a:pPr>
-            <a:r>
-              <a:rPr lang="en-GB" dirty="0"/>
-              <a:t>Use of HPC will be only one part of your activities associated with your work and may not even be the largest source of carbon emissions.</a:t>
-            </a:r>
-          </a:p>
-          <a:p>
-            <a:pPr marL="0" indent="0">
-              <a:buNone/>
-            </a:pPr>
-            <a:endParaRPr lang="en-GB" dirty="0"/>
-          </a:p>
-          <a:p>
-            <a:r>
-              <a:rPr lang="en-GB" dirty="0"/>
-              <a:t>List sources of carbon emissions from your work activities other than via HPC systems</a:t>
-            </a:r>
-          </a:p>
-          <a:p>
-            <a:r>
-              <a:rPr lang="en-GB" dirty="0"/>
-              <a:t>Try to rank them in order of what you think the largest will be to the smallest</a:t>
-            </a:r>
-          </a:p>
-          <a:p>
-            <a:pPr marL="0" indent="0">
-              <a:buNone/>
-            </a:pPr>
-            <a:endParaRPr lang="en-GB" dirty="0"/>
-          </a:p>
-        </p:txBody>
-      </p:sp>
-    </p:spTree>
-    <p:extLst>
-      <p:ext uri="{BB962C8B-B14F-4D97-AF65-F5344CB8AC3E}">
-        <p14:creationId xmlns:p14="http://schemas.microsoft.com/office/powerpoint/2010/main" val="1336928419"/>
-      </p:ext>
-    </p:extLst>
-  </p:cSld>
-  <p:clrMapOvr>
-    <a:masterClrMapping/>
-  </p:clrMapOvr>
-</p:sld>
-</file>
-
 <file path=ppt/slides/slide9.xml><?xml version="1.0" encoding="utf-8"?>
 <p:sld xmlns:a="http://schemas.openxmlformats.org/drawingml/2006/main" xmlns:r="http://schemas.openxmlformats.org/officeDocument/2006/relationships" xmlns:p="http://schemas.openxmlformats.org/presentationml/2006/main">
   <p:cSld>
@@ -6552,7 +6923,7 @@
           <p:cNvPr id="2" name="Title 1">
             <a:extLst>
               <a:ext uri="{FF2B5EF4-FFF2-40B4-BE49-F238E27FC236}">
-                <a16:creationId xmlns:a16="http://schemas.microsoft.com/office/drawing/2014/main" id="{A14A4F2D-67FE-A40B-38A1-FE15430A041C}"/>
+                <a16:creationId xmlns:a16="http://schemas.microsoft.com/office/drawing/2014/main" id="{BC120409-6EB5-E11A-0230-8D3F0B1134E9}"/>
               </a:ext>
             </a:extLst>
           </p:cNvPr>
@@ -6570,7 +6941,7 @@
           <a:p>
             <a:r>
               <a:rPr lang="en-GB" dirty="0"/>
-              <a:t>Solution</a:t>
+              <a:t>Course overview</a:t>
             </a:r>
           </a:p>
         </p:txBody>
@@ -6580,7 +6951,7 @@
           <p:cNvPr id="3" name="Content Placeholder 2">
             <a:extLst>
               <a:ext uri="{FF2B5EF4-FFF2-40B4-BE49-F238E27FC236}">
-                <a16:creationId xmlns:a16="http://schemas.microsoft.com/office/drawing/2014/main" id="{681A15F2-B311-C881-92C3-93622D9DC6C9}"/>
+                <a16:creationId xmlns:a16="http://schemas.microsoft.com/office/drawing/2014/main" id="{FE3C14D3-ECF9-CFCD-8788-F6332655D99D}"/>
               </a:ext>
             </a:extLst>
           </p:cNvPr>
@@ -6593,13 +6964,13 @@
         </p:nvSpPr>
         <p:spPr>
           <a:xfrm>
-            <a:off x="838199" y="1494971"/>
-            <a:ext cx="10515601" cy="4997904"/>
+            <a:off x="838200" y="1509486"/>
+            <a:ext cx="10515600" cy="4983389"/>
           </a:xfrm>
         </p:spPr>
         <p:txBody>
           <a:bodyPr>
-            <a:normAutofit fontScale="62500" lnSpcReduction="20000"/>
+            <a:normAutofit fontScale="77500" lnSpcReduction="20000"/>
           </a:bodyPr>
           <a:lstStyle/>
           <a:p>
@@ -6608,104 +6979,117 @@
             </a:pPr>
             <a:r>
               <a:rPr lang="en-GB" dirty="0"/>
-              <a:t>You may have come up with activities from the list below</a:t>
-            </a:r>
-          </a:p>
-          <a:p>
-            <a:pPr marL="0" indent="0">
-              <a:buNone/>
-            </a:pPr>
-            <a:endParaRPr lang="en-GB" dirty="0"/>
-          </a:p>
-          <a:p>
-            <a:r>
-              <a:rPr lang="en-GB" dirty="0"/>
-              <a:t>Travel to/from place of work</a:t>
-            </a:r>
-          </a:p>
-          <a:p>
-            <a:r>
-              <a:rPr lang="en-GB" dirty="0"/>
-              <a:t>Travel and accommodation for conferences, training and meetings</a:t>
-            </a:r>
-          </a:p>
-          <a:p>
-            <a:r>
-              <a:rPr lang="en-GB" dirty="0"/>
-              <a:t>Use of non-HPC computing resources</a:t>
-            </a:r>
-          </a:p>
-          <a:p>
-            <a:pPr lvl="1"/>
-            <a:r>
-              <a:rPr lang="en-GB" dirty="0"/>
-              <a:t>e.g. laptops/workstations, cloud resources and the internet</a:t>
-            </a:r>
-          </a:p>
-          <a:p>
-            <a:r>
-              <a:rPr lang="en-GB" dirty="0"/>
-              <a:t>Data storage</a:t>
-            </a:r>
-          </a:p>
-          <a:p>
-            <a:r>
-              <a:rPr lang="en-GB" dirty="0"/>
-              <a:t>Laboratory work, e.g. chemicals, instruments</a:t>
-            </a:r>
-          </a:p>
-          <a:p>
-            <a:r>
-              <a:rPr lang="en-GB" dirty="0"/>
-              <a:t>Printed materials, e.g. books, journal articles</a:t>
-            </a:r>
-          </a:p>
-          <a:p>
-            <a:pPr marL="0" indent="0">
-              <a:buNone/>
-            </a:pPr>
-            <a:endParaRPr lang="en-GB" dirty="0"/>
-          </a:p>
-          <a:p>
-            <a:pPr marL="0" indent="0">
-              <a:buNone/>
-            </a:pPr>
-            <a:r>
-              <a:rPr lang="en-GB" dirty="0"/>
-              <a:t>Ordering these by size of emission is more difficult and will differ from person to person.</a:t>
-            </a:r>
-          </a:p>
-          <a:p>
-            <a:pPr marL="0" indent="0">
-              <a:buNone/>
-            </a:pPr>
-            <a:r>
-              <a:rPr lang="en-GB" dirty="0"/>
-              <a:t>Typically, any sort of flying to conferences or meetings will be the most carbon intensive activity you can undertake through your work. Whether this is the largest contribution depends on how often you fly.</a:t>
-            </a:r>
-          </a:p>
-          <a:p>
-            <a:pPr marL="0" indent="0">
-              <a:buNone/>
-            </a:pPr>
-            <a:r>
-              <a:rPr lang="en-GB" dirty="0"/>
-              <a:t>If you work in a laboratory, that may well be the next highest source of emissions.</a:t>
+              <a:t>During this course, we will cover six key areas of green HPC, derived from the principles of green software engineering.</a:t>
             </a:r>
             <a:br>
               <a:rPr lang="en-GB" dirty="0"/>
             </a:br>
+            <a:endParaRPr lang="en-GB" dirty="0"/>
+          </a:p>
+          <a:p>
+            <a:r>
+              <a:rPr lang="en-GB" b="1" dirty="0"/>
+              <a:t>Carbon Efficiency</a:t>
+            </a:r>
             <a:r>
               <a:rPr lang="en-GB" dirty="0"/>
-              <a:t>Use of a petrol/diesel may also place highly, especially if you have a long commute and travel alone.</a:t>
-            </a:r>
+              <a:t>: Emit the least amount of carbon possible.</a:t>
+            </a:r>
+          </a:p>
+          <a:p>
+            <a:r>
+              <a:rPr lang="en-GB" b="1" dirty="0"/>
+              <a:t>Energy Efficiency</a:t>
+            </a:r>
+            <a:r>
+              <a:rPr lang="en-GB" dirty="0"/>
+              <a:t>: Use the least amount of energy possible.</a:t>
+            </a:r>
+          </a:p>
+          <a:p>
+            <a:r>
+              <a:rPr lang="en-GB" b="1" dirty="0"/>
+              <a:t>Carbon Awareness</a:t>
+            </a:r>
+            <a:r>
+              <a:rPr lang="en-GB" dirty="0"/>
+              <a:t>: Do more when the electricity is "cleaner" and do less when the electricity is "dirtier".</a:t>
+            </a:r>
+          </a:p>
+          <a:p>
+            <a:r>
+              <a:rPr lang="en-GB" b="1" dirty="0"/>
+              <a:t>Hardware Efficiency</a:t>
+            </a:r>
+            <a:r>
+              <a:rPr lang="en-GB" dirty="0"/>
+              <a:t>: Use the least amount of embodied carbon possible.</a:t>
+            </a:r>
+          </a:p>
+          <a:p>
+            <a:r>
+              <a:rPr lang="en-GB" b="1" dirty="0"/>
+              <a:t>Measurement</a:t>
+            </a:r>
+            <a:r>
+              <a:rPr lang="en-GB" dirty="0"/>
+              <a:t>: What you cannot measure, you cannot improve.</a:t>
+            </a:r>
+          </a:p>
+          <a:p>
+            <a:r>
+              <a:rPr lang="en-GB" b="1" dirty="0"/>
+              <a:t>Reducing Emissions</a:t>
+            </a:r>
+            <a:r>
+              <a:rPr lang="en-GB" dirty="0"/>
+              <a:t>: Understand mechanisms of carbon reduction.</a:t>
+            </a:r>
+            <a:br>
+              <a:rPr lang="en-GB" dirty="0"/>
+            </a:br>
+            <a:endParaRPr lang="en-GB" dirty="0"/>
+          </a:p>
+          <a:p>
+            <a:pPr marL="0" indent="0">
+              <a:buNone/>
+            </a:pPr>
+            <a:r>
+              <a:rPr lang="en-GB" dirty="0"/>
+              <a:t>For each area, we'll introduce some new concepts and explain in detail why it is important in terms of the climate, and how you can apply them on HPC systems.</a:t>
+            </a:r>
+          </a:p>
+          <a:p>
+            <a:pPr marL="0" indent="0">
+              <a:buNone/>
+            </a:pPr>
+            <a:r>
+              <a:rPr lang="en-GB" dirty="0"/>
+              <a:t>We will use the </a:t>
+            </a:r>
+            <a:r>
+              <a:rPr lang="en-GB" dirty="0">
+                <a:hlinkClick r:id="rId2"/>
+              </a:rPr>
+              <a:t>ARCHER2 UK National Supercomputing Service</a:t>
+            </a:r>
+            <a:r>
+              <a:rPr lang="en-GB" dirty="0"/>
+              <a:t> to provide concrete examples of how the principles can be applied.</a:t>
+            </a:r>
+          </a:p>
+          <a:p>
+            <a:pPr marL="0" indent="0">
+              <a:buNone/>
+            </a:pPr>
+            <a:endParaRPr lang="en-GB" dirty="0"/>
           </a:p>
         </p:txBody>
       </p:sp>
     </p:spTree>
     <p:extLst>
       <p:ext uri="{BB962C8B-B14F-4D97-AF65-F5344CB8AC3E}">
-        <p14:creationId xmlns:p14="http://schemas.microsoft.com/office/powerpoint/2010/main" val="2205958413"/>
+        <p14:creationId xmlns:p14="http://schemas.microsoft.com/office/powerpoint/2010/main" val="2548529128"/>
       </p:ext>
     </p:extLst>
   </p:cSld>
@@ -7028,4 +7412,319 @@
     </a:ext>
   </a:extLst>
 </a:theme>
+</file>
+
+<file path=ppt/theme/theme2.xml><?xml version="1.0" encoding="utf-8"?>
+<a:theme xmlns:a="http://schemas.openxmlformats.org/drawingml/2006/main" name="Office Theme">
+  <a:themeElements>
+    <a:clrScheme name="Office">
+      <a:dk1>
+        <a:sysClr val="windowText" lastClr="000000"/>
+      </a:dk1>
+      <a:lt1>
+        <a:sysClr val="window" lastClr="FFFFFF"/>
+      </a:lt1>
+      <a:dk2>
+        <a:srgbClr val="0E2841"/>
+      </a:dk2>
+      <a:lt2>
+        <a:srgbClr val="E8E8E8"/>
+      </a:lt2>
+      <a:accent1>
+        <a:srgbClr val="156082"/>
+      </a:accent1>
+      <a:accent2>
+        <a:srgbClr val="E97132"/>
+      </a:accent2>
+      <a:accent3>
+        <a:srgbClr val="196B24"/>
+      </a:accent3>
+      <a:accent4>
+        <a:srgbClr val="0F9ED5"/>
+      </a:accent4>
+      <a:accent5>
+        <a:srgbClr val="A02B93"/>
+      </a:accent5>
+      <a:accent6>
+        <a:srgbClr val="4EA72E"/>
+      </a:accent6>
+      <a:hlink>
+        <a:srgbClr val="467886"/>
+      </a:hlink>
+      <a:folHlink>
+        <a:srgbClr val="96607D"/>
+      </a:folHlink>
+    </a:clrScheme>
+    <a:fontScheme name="Office">
+      <a:majorFont>
+        <a:latin typeface="Aptos Display" panose="02110004020202020204"/>
+        <a:ea typeface=""/>
+        <a:cs typeface=""/>
+        <a:font script="Jpan" typeface="游ゴシック Light"/>
+        <a:font script="Hang" typeface="맑은 고딕"/>
+        <a:font script="Hans" typeface="等线 Light"/>
+        <a:font script="Hant" typeface="新細明體"/>
+        <a:font script="Arab" typeface="Times New Roman"/>
+        <a:font script="Hebr" typeface="Times New Roman"/>
+        <a:font script="Thai" typeface="Angsana New"/>
+        <a:font script="Ethi" typeface="Nyala"/>
+        <a:font script="Beng" typeface="Vrinda"/>
+        <a:font script="Gujr" typeface="Shruti"/>
+        <a:font script="Khmr" typeface="MoolBoran"/>
+        <a:font script="Knda" typeface="Tunga"/>
+        <a:font script="Guru" typeface="Raavi"/>
+        <a:font script="Cans" typeface="Euphemia"/>
+        <a:font script="Cher" typeface="Plantagenet Cherokee"/>
+        <a:font script="Yiii" typeface="Microsoft Yi Baiti"/>
+        <a:font script="Tibt" typeface="Microsoft Himalaya"/>
+        <a:font script="Thaa" typeface="MV Boli"/>
+        <a:font script="Deva" typeface="Mangal"/>
+        <a:font script="Telu" typeface="Gautami"/>
+        <a:font script="Taml" typeface="Latha"/>
+        <a:font script="Syrc" typeface="Estrangelo Edessa"/>
+        <a:font script="Orya" typeface="Kalinga"/>
+        <a:font script="Mlym" typeface="Kartika"/>
+        <a:font script="Laoo" typeface="DokChampa"/>
+        <a:font script="Sinh" typeface="Iskoola Pota"/>
+        <a:font script="Mong" typeface="Mongolian Baiti"/>
+        <a:font script="Viet" typeface="Times New Roman"/>
+        <a:font script="Uigh" typeface="Microsoft Uighur"/>
+        <a:font script="Geor" typeface="Sylfaen"/>
+        <a:font script="Armn" typeface="Arial"/>
+        <a:font script="Bugi" typeface="Leelawadee UI"/>
+        <a:font script="Bopo" typeface="Microsoft JhengHei"/>
+        <a:font script="Java" typeface="Javanese Text"/>
+        <a:font script="Lisu" typeface="Segoe UI"/>
+        <a:font script="Mymr" typeface="Myanmar Text"/>
+        <a:font script="Nkoo" typeface="Ebrima"/>
+        <a:font script="Olck" typeface="Nirmala UI"/>
+        <a:font script="Osma" typeface="Ebrima"/>
+        <a:font script="Phag" typeface="Phagspa"/>
+        <a:font script="Syrn" typeface="Estrangelo Edessa"/>
+        <a:font script="Syrj" typeface="Estrangelo Edessa"/>
+        <a:font script="Syre" typeface="Estrangelo Edessa"/>
+        <a:font script="Sora" typeface="Nirmala UI"/>
+        <a:font script="Tale" typeface="Microsoft Tai Le"/>
+        <a:font script="Talu" typeface="Microsoft New Tai Lue"/>
+        <a:font script="Tfng" typeface="Ebrima"/>
+      </a:majorFont>
+      <a:minorFont>
+        <a:latin typeface="Aptos" panose="02110004020202020204"/>
+        <a:ea typeface=""/>
+        <a:cs typeface=""/>
+        <a:font script="Jpan" typeface="游ゴシック"/>
+        <a:font script="Hang" typeface="맑은 고딕"/>
+        <a:font script="Hans" typeface="等线"/>
+        <a:font script="Hant" typeface="新細明體"/>
+        <a:font script="Arab" typeface="Arial"/>
+        <a:font script="Hebr" typeface="Arial"/>
+        <a:font script="Thai" typeface="Cordia New"/>
+        <a:font script="Ethi" typeface="Nyala"/>
+        <a:font script="Beng" typeface="Vrinda"/>
+        <a:font script="Gujr" typeface="Shruti"/>
+        <a:font script="Khmr" typeface="DaunPenh"/>
+        <a:font script="Knda" typeface="Tunga"/>
+        <a:font script="Guru" typeface="Raavi"/>
+        <a:font script="Cans" typeface="Euphemia"/>
+        <a:font script="Cher" typeface="Plantagenet Cherokee"/>
+        <a:font script="Yiii" typeface="Microsoft Yi Baiti"/>
+        <a:font script="Tibt" typeface="Microsoft Himalaya"/>
+        <a:font script="Thaa" typeface="MV Boli"/>
+        <a:font script="Deva" typeface="Mangal"/>
+        <a:font script="Telu" typeface="Gautami"/>
+        <a:font script="Taml" typeface="Latha"/>
+        <a:font script="Syrc" typeface="Estrangelo Edessa"/>
+        <a:font script="Orya" typeface="Kalinga"/>
+        <a:font script="Mlym" typeface="Kartika"/>
+        <a:font script="Laoo" typeface="DokChampa"/>
+        <a:font script="Sinh" typeface="Iskoola Pota"/>
+        <a:font script="Mong" typeface="Mongolian Baiti"/>
+        <a:font script="Viet" typeface="Arial"/>
+        <a:font script="Uigh" typeface="Microsoft Uighur"/>
+        <a:font script="Geor" typeface="Sylfaen"/>
+        <a:font script="Armn" typeface="Arial"/>
+        <a:font script="Bugi" typeface="Leelawadee UI"/>
+        <a:font script="Bopo" typeface="Microsoft JhengHei"/>
+        <a:font script="Java" typeface="Javanese Text"/>
+        <a:font script="Lisu" typeface="Segoe UI"/>
+        <a:font script="Mymr" typeface="Myanmar Text"/>
+        <a:font script="Nkoo" typeface="Ebrima"/>
+        <a:font script="Olck" typeface="Nirmala UI"/>
+        <a:font script="Osma" typeface="Ebrima"/>
+        <a:font script="Phag" typeface="Phagspa"/>
+        <a:font script="Syrn" typeface="Estrangelo Edessa"/>
+        <a:font script="Syrj" typeface="Estrangelo Edessa"/>
+        <a:font script="Syre" typeface="Estrangelo Edessa"/>
+        <a:font script="Sora" typeface="Nirmala UI"/>
+        <a:font script="Tale" typeface="Microsoft Tai Le"/>
+        <a:font script="Talu" typeface="Microsoft New Tai Lue"/>
+        <a:font script="Tfng" typeface="Ebrima"/>
+      </a:minorFont>
+    </a:fontScheme>
+    <a:fmtScheme name="Office">
+      <a:fillStyleLst>
+        <a:solidFill>
+          <a:schemeClr val="phClr"/>
+        </a:solidFill>
+        <a:gradFill rotWithShape="1">
+          <a:gsLst>
+            <a:gs pos="0">
+              <a:schemeClr val="phClr">
+                <a:lumMod val="110000"/>
+                <a:satMod val="105000"/>
+                <a:tint val="67000"/>
+              </a:schemeClr>
+            </a:gs>
+            <a:gs pos="50000">
+              <a:schemeClr val="phClr">
+                <a:lumMod val="105000"/>
+                <a:satMod val="103000"/>
+                <a:tint val="73000"/>
+              </a:schemeClr>
+            </a:gs>
+            <a:gs pos="100000">
+              <a:schemeClr val="phClr">
+                <a:lumMod val="105000"/>
+                <a:satMod val="109000"/>
+                <a:tint val="81000"/>
+              </a:schemeClr>
+            </a:gs>
+          </a:gsLst>
+          <a:lin ang="5400000" scaled="0"/>
+        </a:gradFill>
+        <a:gradFill rotWithShape="1">
+          <a:gsLst>
+            <a:gs pos="0">
+              <a:schemeClr val="phClr">
+                <a:satMod val="103000"/>
+                <a:lumMod val="102000"/>
+                <a:tint val="94000"/>
+              </a:schemeClr>
+            </a:gs>
+            <a:gs pos="50000">
+              <a:schemeClr val="phClr">
+                <a:satMod val="110000"/>
+                <a:lumMod val="100000"/>
+                <a:shade val="100000"/>
+              </a:schemeClr>
+            </a:gs>
+            <a:gs pos="100000">
+              <a:schemeClr val="phClr">
+                <a:lumMod val="99000"/>
+                <a:satMod val="120000"/>
+                <a:shade val="78000"/>
+              </a:schemeClr>
+            </a:gs>
+          </a:gsLst>
+          <a:lin ang="5400000" scaled="0"/>
+        </a:gradFill>
+      </a:fillStyleLst>
+      <a:lnStyleLst>
+        <a:ln w="12700" cap="flat" cmpd="sng" algn="ctr">
+          <a:solidFill>
+            <a:schemeClr val="phClr"/>
+          </a:solidFill>
+          <a:prstDash val="solid"/>
+          <a:miter lim="800000"/>
+        </a:ln>
+        <a:ln w="19050" cap="flat" cmpd="sng" algn="ctr">
+          <a:solidFill>
+            <a:schemeClr val="phClr"/>
+          </a:solidFill>
+          <a:prstDash val="solid"/>
+          <a:miter lim="800000"/>
+        </a:ln>
+        <a:ln w="25400" cap="flat" cmpd="sng" algn="ctr">
+          <a:solidFill>
+            <a:schemeClr val="phClr"/>
+          </a:solidFill>
+          <a:prstDash val="solid"/>
+          <a:miter lim="800000"/>
+        </a:ln>
+      </a:lnStyleLst>
+      <a:effectStyleLst>
+        <a:effectStyle>
+          <a:effectLst/>
+        </a:effectStyle>
+        <a:effectStyle>
+          <a:effectLst/>
+        </a:effectStyle>
+        <a:effectStyle>
+          <a:effectLst>
+            <a:outerShdw blurRad="57150" dist="19050" dir="5400000" algn="ctr" rotWithShape="0">
+              <a:srgbClr val="000000">
+                <a:alpha val="63000"/>
+              </a:srgbClr>
+            </a:outerShdw>
+          </a:effectLst>
+        </a:effectStyle>
+      </a:effectStyleLst>
+      <a:bgFillStyleLst>
+        <a:solidFill>
+          <a:schemeClr val="phClr"/>
+        </a:solidFill>
+        <a:solidFill>
+          <a:schemeClr val="phClr">
+            <a:tint val="95000"/>
+            <a:satMod val="170000"/>
+          </a:schemeClr>
+        </a:solidFill>
+        <a:gradFill rotWithShape="1">
+          <a:gsLst>
+            <a:gs pos="0">
+              <a:schemeClr val="phClr">
+                <a:tint val="93000"/>
+                <a:satMod val="150000"/>
+                <a:shade val="98000"/>
+                <a:lumMod val="102000"/>
+              </a:schemeClr>
+            </a:gs>
+            <a:gs pos="50000">
+              <a:schemeClr val="phClr">
+                <a:tint val="98000"/>
+                <a:satMod val="130000"/>
+                <a:shade val="90000"/>
+                <a:lumMod val="103000"/>
+              </a:schemeClr>
+            </a:gs>
+            <a:gs pos="100000">
+              <a:schemeClr val="phClr">
+                <a:shade val="63000"/>
+                <a:satMod val="120000"/>
+              </a:schemeClr>
+            </a:gs>
+          </a:gsLst>
+          <a:lin ang="5400000" scaled="0"/>
+        </a:gradFill>
+      </a:bgFillStyleLst>
+    </a:fmtScheme>
+  </a:themeElements>
+  <a:objectDefaults>
+    <a:lnDef>
+      <a:spPr/>
+      <a:bodyPr/>
+      <a:lstStyle/>
+      <a:style>
+        <a:lnRef idx="2">
+          <a:schemeClr val="accent1"/>
+        </a:lnRef>
+        <a:fillRef idx="0">
+          <a:schemeClr val="accent1"/>
+        </a:fillRef>
+        <a:effectRef idx="1">
+          <a:schemeClr val="accent1"/>
+        </a:effectRef>
+        <a:fontRef idx="minor">
+          <a:schemeClr val="tx1"/>
+        </a:fontRef>
+      </a:style>
+    </a:lnDef>
+  </a:objectDefaults>
+  <a:extraClrSchemeLst/>
+  <a:extLst>
+    <a:ext uri="{05A4C25C-085E-4340-85A3-A5531E510DB2}">
+      <thm15:themeFamily xmlns:thm15="http://schemas.microsoft.com/office/thememl/2012/main" name="Office Theme" id="{2E142A2C-CD16-42D6-873A-C26D2A0506FA}" vid="{1BDDFF52-6CD6-40A5-AB3C-68EB2F1E4D0A}"/>
+    </a:ext>
+  </a:extLst>
+</a:theme>
 </file>
</xml_diff>